<commit_message>
Rollout: show what is built instead of a timeline
The pilot and most of the automate phase already exist, so the deck slide and
README section 12 now give each phase a status instead of a duration.

Co-Authored-By: Claude Opus 5.5 <noreply@anthropic.com>
</commit_message>
<xml_diff>
--- a/DevExAI.pptx
+++ b/DevExAI.pptx
@@ -169,7 +169,7 @@
     </p:spTree>
     <p:extLst>
       <p:ext uri="{BB962C8B-B14F-4D97-AF65-F5344CB8AC3E}">
-        <p14:creationId xmlns:p14="http://schemas.microsoft.com/office/powerpoint/2010/main" val="2482950680"/>
+        <p14:creationId xmlns:p14="http://schemas.microsoft.com/office/powerpoint/2010/main" val="2743842129"/>
       </p:ext>
     </p:extLst>
   </p:cSld>
@@ -798,7 +798,7 @@
           <a:p>
             <a:fld id="{5BCAD085-E8A6-8845-BD4E-CB4CCA059FC4}" type="datetimeFigureOut">
               <a:rPr lang="en-US" smtClean="0"/>
-              <a:t>10/20/2026</a:t>
+              <a:t>10/22/2026</a:t>
             </a:fld>
             <a:endParaRPr lang="en-US"/>
           </a:p>
@@ -966,7 +966,7 @@
           <a:p>
             <a:fld id="{5BCAD085-E8A6-8845-BD4E-CB4CCA059FC4}" type="datetimeFigureOut">
               <a:rPr lang="en-US" smtClean="0"/>
-              <a:t>10/20/2026</a:t>
+              <a:t>10/22/2026</a:t>
             </a:fld>
             <a:endParaRPr lang="en-US"/>
           </a:p>
@@ -1144,7 +1144,7 @@
           <a:p>
             <a:fld id="{5BCAD085-E8A6-8845-BD4E-CB4CCA059FC4}" type="datetimeFigureOut">
               <a:rPr lang="en-US" smtClean="0"/>
-              <a:t>10/20/2026</a:t>
+              <a:t>10/22/2026</a:t>
             </a:fld>
             <a:endParaRPr lang="en-US"/>
           </a:p>
@@ -1312,7 +1312,7 @@
           <a:p>
             <a:fld id="{5BCAD085-E8A6-8845-BD4E-CB4CCA059FC4}" type="datetimeFigureOut">
               <a:rPr lang="en-US" smtClean="0"/>
-              <a:t>10/20/2026</a:t>
+              <a:t>10/22/2026</a:t>
             </a:fld>
             <a:endParaRPr lang="en-US"/>
           </a:p>
@@ -1557,7 +1557,7 @@
           <a:p>
             <a:fld id="{5BCAD085-E8A6-8845-BD4E-CB4CCA059FC4}" type="datetimeFigureOut">
               <a:rPr lang="en-US" smtClean="0"/>
-              <a:t>10/20/2026</a:t>
+              <a:t>10/22/2026</a:t>
             </a:fld>
             <a:endParaRPr lang="en-US"/>
           </a:p>
@@ -1842,7 +1842,7 @@
           <a:p>
             <a:fld id="{5BCAD085-E8A6-8845-BD4E-CB4CCA059FC4}" type="datetimeFigureOut">
               <a:rPr lang="en-US" smtClean="0"/>
-              <a:t>10/20/2026</a:t>
+              <a:t>10/22/2026</a:t>
             </a:fld>
             <a:endParaRPr lang="en-US"/>
           </a:p>
@@ -2261,7 +2261,7 @@
           <a:p>
             <a:fld id="{5BCAD085-E8A6-8845-BD4E-CB4CCA059FC4}" type="datetimeFigureOut">
               <a:rPr lang="en-US" smtClean="0"/>
-              <a:t>10/20/2026</a:t>
+              <a:t>10/22/2026</a:t>
             </a:fld>
             <a:endParaRPr lang="en-US"/>
           </a:p>
@@ -2378,7 +2378,7 @@
           <a:p>
             <a:fld id="{5BCAD085-E8A6-8845-BD4E-CB4CCA059FC4}" type="datetimeFigureOut">
               <a:rPr lang="en-US" smtClean="0"/>
-              <a:t>10/20/2026</a:t>
+              <a:t>10/22/2026</a:t>
             </a:fld>
             <a:endParaRPr lang="en-US"/>
           </a:p>
@@ -2473,7 +2473,7 @@
           <a:p>
             <a:fld id="{5BCAD085-E8A6-8845-BD4E-CB4CCA059FC4}" type="datetimeFigureOut">
               <a:rPr lang="en-US" smtClean="0"/>
-              <a:t>10/20/2026</a:t>
+              <a:t>10/22/2026</a:t>
             </a:fld>
             <a:endParaRPr lang="en-US"/>
           </a:p>
@@ -2748,7 +2748,7 @@
           <a:p>
             <a:fld id="{5BCAD085-E8A6-8845-BD4E-CB4CCA059FC4}" type="datetimeFigureOut">
               <a:rPr lang="en-US" smtClean="0"/>
-              <a:t>10/20/2026</a:t>
+              <a:t>10/22/2026</a:t>
             </a:fld>
             <a:endParaRPr lang="en-US"/>
           </a:p>
@@ -3000,7 +3000,7 @@
           <a:p>
             <a:fld id="{5BCAD085-E8A6-8845-BD4E-CB4CCA059FC4}" type="datetimeFigureOut">
               <a:rPr lang="en-US" smtClean="0"/>
-              <a:t>10/20/2026</a:t>
+              <a:t>10/22/2026</a:t>
             </a:fld>
             <a:endParaRPr lang="en-US"/>
           </a:p>
@@ -3211,7 +3211,7 @@
           <a:p>
             <a:fld id="{5BCAD085-E8A6-8845-BD4E-CB4CCA059FC4}" type="datetimeFigureOut">
               <a:rPr lang="en-US" smtClean="0"/>
-              <a:t>10/20/2026</a:t>
+              <a:t>10/22/2026</a:t>
             </a:fld>
             <a:endParaRPr lang="en-US"/>
           </a:p>
@@ -14270,7 +14270,7 @@
                 </a:solidFill>
                 <a:latin typeface="Arial"/>
               </a:rPr>
-              <a:t>Start small, then grow into a product</a:t>
+              <a:t>The core is built; next, grow it into a product</a:t>
             </a:r>
           </a:p>
         </p:txBody>
@@ -14553,11 +14553,11 @@
             <a:r>
               <a:rPr sz="1400" b="1" i="0">
                 <a:solidFill>
-                  <a:srgbClr val="B45309"/>
+                  <a:srgbClr val="0F766E"/>
                 </a:solidFill>
                 <a:latin typeface="Arial"/>
               </a:rPr>
-              <a:t>2–3 weeks</a:t>
+              <a:t>Built</a:t>
             </a:r>
           </a:p>
         </p:txBody>
@@ -14596,7 +14596,7 @@
                 </a:solidFill>
                 <a:latin typeface="Arial"/>
               </a:rPr>
-              <a:t>Slack intake (our platform), safety gate, plan, human-built tool, manual post. One team.</a:t>
+              <a:t>Slack intake (our platform), safety gate, plan, dashboard, blog post. One team.</a:t>
             </a:r>
           </a:p>
         </p:txBody>
@@ -14801,11 +14801,11 @@
             <a:r>
               <a:rPr sz="1400" b="1" i="0">
                 <a:solidFill>
-                  <a:srgbClr val="B45309"/>
+                  <a:srgbClr val="0F766E"/>
                 </a:solidFill>
                 <a:latin typeface="Arial"/>
               </a:rPr>
-              <a:t>3–4 weeks</a:t>
+              <a:t>Mostly built</a:t>
             </a:r>
           </a:p>
         </p:txBody>
@@ -14844,7 +14844,7 @@
                 </a:solidFill>
                 <a:latin typeface="Arial"/>
               </a:rPr>
-              <a:t>Cheap builder, tests, Opus review, auto post, install command, account pool.</a:t>
+              <a:t>Built: builder, Opus review, auto post. Next: tests in a sandbox, install command, account pool.</a:t>
             </a:r>
           </a:p>
         </p:txBody>
@@ -15053,7 +15053,7 @@
                 </a:solidFill>
                 <a:latin typeface="Arial"/>
               </a:rPr>
-              <a:t>Ongoing</a:t>
+              <a:t>Next</a:t>
             </a:r>
           </a:p>
         </p:txBody>
@@ -15301,7 +15301,7 @@
                 </a:solidFill>
                 <a:latin typeface="Arial"/>
               </a:rPr>
-              <a:t>After phase 3</a:t>
+              <a:t>Started</a:t>
             </a:r>
           </a:p>
         </p:txBody>
@@ -15340,7 +15340,7 @@
                 </a:solidFill>
                 <a:latin typeface="Arial"/>
               </a:rPr>
-              <a:t>Second chat platform (e.g. Teams), settings file, setup guide.</a:t>
+              <a:t>Windows package and updater exist. Next: Linux, second chat platform (e.g. Teams).</a:t>
             </a:r>
           </a:p>
         </p:txBody>

</xml_diff>

<commit_message>
Deck: match what the code does today
Builder is Opus for now, Claude Code files only; stages without Testing;
24-hour reassignment; links read by a secret-free process; blog built into
the dashboard; product runs from a self-updating Windows/Linux package;
account pool marked planned; open questions slide now lists the decisions.
README section 8 matches.

Co-Authored-By: Claude Opus 5.5 <noreply@anthropic.com>
</commit_message>
<xml_diff>
--- a/DevExAI.pptx
+++ b/DevExAI.pptx
@@ -169,7 +169,7 @@
     </p:spTree>
     <p:extLst>
       <p:ext uri="{BB962C8B-B14F-4D97-AF65-F5344CB8AC3E}">
-        <p14:creationId xmlns:p14="http://schemas.microsoft.com/office/powerpoint/2010/main" val="2743842129"/>
+        <p14:creationId xmlns:p14="http://schemas.microsoft.com/office/powerpoint/2010/main" val="1857724115"/>
       </p:ext>
     </p:extLst>
   </p:cSld>
@@ -5342,7 +5342,7 @@
                 </a:solidFill>
                 <a:latin typeface="Arial"/>
               </a:rPr>
-              <a:t>Three assistants supported at launch — more later</a:t>
+              <a:t>Claude Code first; Gemini CLI and Codex next</a:t>
             </a:r>
           </a:p>
         </p:txBody>
@@ -5639,7 +5639,7 @@
                 </a:solidFill>
                 <a:latin typeface="Arial"/>
               </a:rPr>
-              <a:t>One shared core with a thin adapter per assistant, so an idea is never rebuilt three times.</a:t>
+              <a:t>The builder writes Claude Code files today. Later: one shared core with a thin adapter per assistant, so an idea is never rebuilt three times.</a:t>
             </a:r>
           </a:p>
         </p:txBody>
@@ -8235,7 +8235,7 @@
                 </a:solidFill>
                 <a:latin typeface="Arial"/>
               </a:rPr>
-              <a:t>Strong models think, cheaper models type</a:t>
+              <a:t>Opus thinks and reviews; cheaper models will type</a:t>
             </a:r>
           </a:p>
         </p:txBody>
@@ -8467,7 +8467,7 @@
                           </a:solidFill>
                           <a:latin typeface="Arial"/>
                         </a:rPr>
-                        <a:t>Claude + standard malware and secret scanners</a:t>
+                        <a:t>Claude Opus; malware and secret scanners to add</a:t>
                       </a:r>
                     </a:p>
                   </a:txBody>
@@ -8613,7 +8613,7 @@
                           </a:solidFill>
                           <a:latin typeface="Arial"/>
                         </a:rPr>
-                        <a:t>Gemini Flash (default); DeepSeek or local model optional</a:t>
+                        <a:t>Claude Opus today; Gemini Flash or a local model planned</a:t>
                       </a:r>
                     </a:p>
                   </a:txBody>
@@ -8759,7 +8759,7 @@
                           </a:solidFill>
                           <a:latin typeface="Arial"/>
                         </a:rPr>
-                        <a:t>Cheap model, checked by Opus</a:t>
+                        <a:t>Written from the approved plan</a:t>
                       </a:r>
                     </a:p>
                   </a:txBody>
@@ -8781,7 +8781,7 @@
                           </a:solidFill>
                           <a:latin typeface="Arial"/>
                         </a:rPr>
-                        <a:t>Short text, low risk.</a:t>
+                        <a:t>No extra model needed.</a:t>
                       </a:r>
                     </a:p>
                   </a:txBody>
@@ -9225,7 +9225,7 @@
                 </a:solidFill>
                 <a:latin typeface="Arial"/>
               </a:rPr>
-              <a:t>Any with bots: Slack, Teams, Google Chat, Discord, Mattermost, and more</a:t>
+              <a:t>Slack today; Teams, Google Chat, Discord and more through a small adapter</a:t>
             </a:r>
           </a:p>
         </p:txBody>
@@ -9350,7 +9350,7 @@
                 </a:solidFill>
                 <a:latin typeface="Arial"/>
               </a:rPr>
-              <a:t>Claude, Gemini, ChatGPT — subscriptions and/or API keys</a:t>
+              <a:t>Claude today; Gemini and ChatGPT next — subscriptions or API keys</a:t>
             </a:r>
           </a:p>
         </p:txBody>
@@ -9475,7 +9475,7 @@
                 </a:solidFill>
                 <a:latin typeface="Arial"/>
               </a:rPr>
-              <a:t>GitHub, GitLab, Bitbucket, Azure DevOps, self-hosted Git</a:t>
+              <a:t>GitHub, GitLab, Bitbucket, Azure DevOps, self-hosted Git (later)</a:t>
             </a:r>
           </a:p>
         </p:txBody>
@@ -9600,7 +9600,7 @@
                 </a:solidFill>
                 <a:latin typeface="Arial"/>
               </a:rPr>
-              <a:t>HashiCorp Vault, or AWS / Google Cloud / Azure</a:t>
+              <a:t>A secret file on the server today; Vault or a cloud secret manager</a:t>
             </a:r>
           </a:p>
         </p:txBody>
@@ -9725,7 +9725,7 @@
                 </a:solidFill>
                 <a:latin typeface="Arial"/>
               </a:rPr>
-              <a:t>The company's own site, wiki, or any site the bot can publish to</a:t>
+              <a:t>Built into the dashboard; posts are Markdown files any site can show</a:t>
             </a:r>
           </a:p>
         </p:txBody>
@@ -9850,7 +9850,7 @@
                 </a:solidFill>
                 <a:latin typeface="Arial"/>
               </a:rPr>
-              <a:t>Cloud VM, own servers, or Docker / Kubernetes</a:t>
+              <a:t>The company's own server, from a Windows or Linux package that updates itself</a:t>
             </a:r>
           </a:p>
         </p:txBody>
@@ -9936,7 +9936,7 @@
                 </a:solidFill>
                 <a:latin typeface="Arial"/>
               </a:rPr>
-              <a:t>Account pool</a:t>
+              <a:t>Account pool (planned)</a:t>
             </a:r>
           </a:p>
         </p:txBody>
@@ -11477,7 +11477,7 @@
                 </a:solidFill>
                 <a:latin typeface="Arial"/>
               </a:rPr>
-              <a:t>• DeepSeek for cheap extra building — off by default (open question 1)</a:t>
+              <a:t>• DeepSeek for cheap extra building — off for now</a:t>
             </a:r>
           </a:p>
           <a:p>
@@ -11685,7 +11685,7 @@
                 </a:solidFill>
                 <a:latin typeface="Arial"/>
               </a:rPr>
-              <a:t>• A small always-on server or cloud VM</a:t>
+              <a:t>• A small always-on server on the company network</a:t>
             </a:r>
           </a:p>
           <a:p>
@@ -11723,7 +11723,7 @@
                 </a:solidFill>
                 <a:latin typeface="Arial"/>
               </a:rPr>
-              <a:t>• A blog website — custom-built, details later</a:t>
+              <a:t>• The blog, already built into the dashboard</a:t>
             </a:r>
           </a:p>
         </p:txBody>
@@ -18106,7 +18106,7 @@
                           </a:solidFill>
                           <a:latin typeface="Arial"/>
                         </a:rPr>
-                        <a:t>Two safety checks, human approval, sandboxed builds, versions, one-command uninstall, pull a release.</a:t>
+                        <a:t>Two safety checks, human approval, sandboxed builds (next), versions, one-command uninstall, pull a release.</a:t>
                       </a:r>
                     </a:p>
                   </a:txBody>
@@ -18157,7 +18157,7 @@
                           </a:solidFill>
                           <a:latin typeface="Arial"/>
                         </a:rPr>
-                        <a:t>Links read in a sandbox as plain data; no secrets while reading.</a:t>
+                        <a:t>Links read by a separate process as plain data; no secrets while reading.</a:t>
                       </a:r>
                     </a:p>
                   </a:txBody>
@@ -18502,7 +18502,7 @@
                 </a:solidFill>
                 <a:latin typeface="Arial"/>
               </a:rPr>
-              <a:t>17 · OPEN QUESTIONS</a:t>
+              <a:t>17 · DECISIONS</a:t>
             </a:r>
           </a:p>
         </p:txBody>
@@ -18541,7 +18541,7 @@
                 </a:solidFill>
                 <a:latin typeface="Arial"/>
               </a:rPr>
-              <a:t>What we need to decide</a:t>
+              <a:t>What we have decided so far</a:t>
             </a:r>
           </a:p>
         </p:txBody>
@@ -18750,7 +18750,7 @@
                 </a:solidFill>
                 <a:latin typeface="Arial"/>
               </a:rPr>
-              <a:t>Q1</a:t>
+              <a:t>D1</a:t>
             </a:r>
           </a:p>
         </p:txBody>
@@ -18789,7 +18789,7 @@
                 </a:solidFill>
                 <a:latin typeface="Arial"/>
               </a:rPr>
-              <a:t>DeepSeek (optional)</a:t>
+              <a:t>DeepSeek</a:t>
             </a:r>
           </a:p>
         </p:txBody>
@@ -18828,7 +18828,7 @@
                 </a:solidFill>
                 <a:latin typeface="Arial"/>
               </a:rPr>
-              <a:t>Use it only for work with no company code, or run its open models on our own GPU? The plan works without it.</a:t>
+              <a:t>Off for now. Self-hosted models may become a setup option.</a:t>
             </a:r>
           </a:p>
         </p:txBody>
@@ -18959,7 +18959,7 @@
                 </a:solidFill>
                 <a:latin typeface="Arial"/>
               </a:rPr>
-              <a:t>Q2</a:t>
+              <a:t>D2</a:t>
             </a:r>
           </a:p>
         </p:txBody>
@@ -18998,7 +18998,7 @@
                 </a:solidFill>
                 <a:latin typeface="Arial"/>
               </a:rPr>
-              <a:t>Blog website</a:t>
+              <a:t>Blog</a:t>
             </a:r>
           </a:p>
         </p:txBody>
@@ -19037,7 +19037,7 @@
                 </a:solidFill>
                 <a:latin typeface="Arial"/>
               </a:rPr>
-              <a:t>Our own custom-built site. Design, hosting and how the bot publishes are decided later.</a:t>
+              <a:t>Posts are Markdown files, served by the dashboard's own blog page.</a:t>
             </a:r>
           </a:p>
         </p:txBody>
@@ -19104,7 +19104,7 @@
             <a:avLst/>
           </a:prstGeom>
           <a:solidFill>
-            <a:srgbClr val="475569"/>
+            <a:srgbClr val="4338CA"/>
           </a:solidFill>
           <a:ln>
             <a:noFill/>
@@ -19164,11 +19164,11 @@
             <a:r>
               <a:rPr sz="2000" b="1" i="0">
                 <a:solidFill>
-                  <a:srgbClr val="475569"/>
+                  <a:srgbClr val="4338CA"/>
                 </a:solidFill>
                 <a:latin typeface="Arial"/>
               </a:rPr>
-              <a:t>Q3</a:t>
+              <a:t>D3</a:t>
             </a:r>
           </a:p>
         </p:txBody>
@@ -19207,7 +19207,7 @@
                 </a:solidFill>
                 <a:latin typeface="Arial"/>
               </a:rPr>
-              <a:t>First maintainers</a:t>
+              <a:t>Maintainers</a:t>
             </a:r>
           </a:p>
         </p:txBody>
@@ -19246,100 +19246,14 @@
                 </a:solidFill>
                 <a:latin typeface="Arial"/>
               </a:rPr>
-              <a:t>Who they are, and what response time we promise.</a:t>
+              <a:t>Raghav is the pilot's admin and first maintainer. Maintainers answer within 24 hours.</a:t>
             </a:r>
           </a:p>
         </p:txBody>
       </p:sp>
       <p:sp>
         <p:nvSpPr>
-          <p:cNvPr id="21" name="build03 Rounded Rectangle 20"/>
-          <p:cNvSpPr/>
-          <p:nvPr/>
-        </p:nvSpPr>
-        <p:spPr>
-          <a:xfrm>
-            <a:off x="4632807" y="4069080"/>
-            <a:ext cx="1051560" cy="411480"/>
-          </a:xfrm>
-          <a:prstGeom prst="roundRect">
-            <a:avLst>
-              <a:gd name="adj" fmla="val 30000"/>
-            </a:avLst>
-          </a:prstGeom>
-          <a:solidFill>
-            <a:srgbClr val="FEF3C7"/>
-          </a:solidFill>
-          <a:ln>
-            <a:noFill/>
-          </a:ln>
-          <a:effectLst/>
-        </p:spPr>
-        <p:style>
-          <a:lnRef idx="1">
-            <a:schemeClr val="accent1"/>
-          </a:lnRef>
-          <a:fillRef idx="3">
-            <a:schemeClr val="accent1"/>
-          </a:fillRef>
-          <a:effectRef idx="2">
-            <a:schemeClr val="accent1"/>
-          </a:effectRef>
-          <a:fontRef idx="minor">
-            <a:schemeClr val="lt1"/>
-          </a:fontRef>
-        </p:style>
-        <p:txBody>
-          <a:bodyPr rtlCol="0" anchor="ctr"/>
-          <a:lstStyle/>
-          <a:p>
-            <a:pPr algn="ctr"/>
-            <a:endParaRPr/>
-          </a:p>
-        </p:txBody>
-      </p:sp>
-      <p:sp>
-        <p:nvSpPr>
-          <p:cNvPr id="22" name="build03 TextBox 21"/>
-          <p:cNvSpPr txBox="1"/>
-          <p:nvPr/>
-        </p:nvSpPr>
-        <p:spPr>
-          <a:xfrm>
-            <a:off x="4705959" y="4069080"/>
-            <a:ext cx="905255" cy="411480"/>
-          </a:xfrm>
-          <a:prstGeom prst="rect">
-            <a:avLst/>
-          </a:prstGeom>
-          <a:noFill/>
-        </p:spPr>
-        <p:txBody>
-          <a:bodyPr wrap="square" lIns="0" tIns="0" rIns="0" bIns="0" anchor="ctr">
-            <a:spAutoFit/>
-          </a:bodyPr>
-          <a:lstStyle/>
-          <a:p>
-            <a:pPr algn="ctr">
-              <a:lnSpc>
-                <a:spcPct val="110000"/>
-              </a:lnSpc>
-            </a:pPr>
-            <a:r>
-              <a:rPr sz="1400" b="1" i="0">
-                <a:solidFill>
-                  <a:srgbClr val="B45309"/>
-                </a:solidFill>
-                <a:latin typeface="Arial"/>
-              </a:rPr>
-              <a:t>Parked</a:t>
-            </a:r>
-          </a:p>
-        </p:txBody>
-      </p:sp>
-      <p:sp>
-        <p:nvSpPr>
-          <p:cNvPr id="23" name="build04 Rounded Rectangle 22"/>
+          <p:cNvPr id="21" name="build04 Rounded Rectangle 20"/>
           <p:cNvSpPr/>
           <p:nvPr/>
         </p:nvSpPr>
@@ -19386,7 +19300,7 @@
       </p:sp>
       <p:sp>
         <p:nvSpPr>
-          <p:cNvPr id="24" name="build04 Rectangle 23"/>
+          <p:cNvPr id="22" name="build04 Rectangle 21"/>
           <p:cNvSpPr/>
           <p:nvPr/>
         </p:nvSpPr>
@@ -19431,7 +19345,7 @@
       </p:sp>
       <p:sp>
         <p:nvSpPr>
-          <p:cNvPr id="25" name="build04 TextBox 24"/>
+          <p:cNvPr id="23" name="build04 TextBox 22"/>
           <p:cNvSpPr txBox="1"/>
           <p:nvPr/>
         </p:nvSpPr>
@@ -19463,14 +19377,14 @@
                 </a:solidFill>
                 <a:latin typeface="Arial"/>
               </a:rPr>
-              <a:t>Q4</a:t>
+              <a:t>D4</a:t>
             </a:r>
           </a:p>
         </p:txBody>
       </p:sp>
       <p:sp>
         <p:nvSpPr>
-          <p:cNvPr id="26" name="build04 TextBox 25"/>
+          <p:cNvPr id="24" name="build04 TextBox 23"/>
           <p:cNvSpPr txBox="1"/>
           <p:nvPr/>
         </p:nvSpPr>
@@ -19509,7 +19423,7 @@
       </p:sp>
       <p:sp>
         <p:nvSpPr>
-          <p:cNvPr id="27" name="build04 TextBox 26"/>
+          <p:cNvPr id="25" name="build04 TextBox 24"/>
           <p:cNvSpPr txBox="1"/>
           <p:nvPr/>
         </p:nvSpPr>
@@ -19541,7 +19455,7 @@
                 </a:solidFill>
                 <a:latin typeface="Arial"/>
               </a:rPr>
-              <a:t>Other companies host it themselves, we host it for them, or both?</a:t>
+              <a:t>Each company hosts it on its own network, from a Windows or Linux package that updates itself.</a:t>
             </a:r>
           </a:p>
         </p:txBody>
@@ -20120,15 +20034,24 @@
                                   </p:childTnLst>
                                 </p:cTn>
                               </p:par>
+                            </p:childTnLst>
+                          </p:cTn>
+                        </p:par>
+                        <p:par>
+                          <p:cTn id="52" fill="hold">
+                            <p:stCondLst>
+                              <p:cond delay="1200"/>
+                            </p:stCondLst>
+                            <p:childTnLst>
                               <p:par>
-                                <p:cTn id="52" presetID="10" presetClass="entr" presetSubtype="0" fill="hold" grpId="0" nodeType="withEffect">
+                                <p:cTn id="53" presetID="10" presetClass="entr" presetSubtype="0" fill="hold" grpId="0" nodeType="afterEffect">
                                   <p:stCondLst>
                                     <p:cond delay="0"/>
                                   </p:stCondLst>
                                   <p:childTnLst>
                                     <p:set>
                                       <p:cBhvr>
-                                        <p:cTn id="53" dur="1" fill="hold">
+                                        <p:cTn id="54" dur="1" fill="hold">
                                           <p:stCondLst>
                                             <p:cond delay="0"/>
                                           </p:stCondLst>
@@ -20146,7 +20069,7 @@
                                     </p:set>
                                     <p:animEffect transition="in" filter="fade">
                                       <p:cBhvr>
-                                        <p:cTn id="54" dur="400"/>
+                                        <p:cTn id="55" dur="400"/>
                                         <p:tgtEl>
                                           <p:spTgt spid="21"/>
                                         </p:tgtEl>
@@ -20156,14 +20079,14 @@
                                 </p:cTn>
                               </p:par>
                               <p:par>
-                                <p:cTn id="55" presetID="10" presetClass="entr" presetSubtype="0" fill="hold" grpId="0" nodeType="withEffect">
+                                <p:cTn id="56" presetID="10" presetClass="entr" presetSubtype="0" fill="hold" grpId="0" nodeType="withEffect">
                                   <p:stCondLst>
                                     <p:cond delay="0"/>
                                   </p:stCondLst>
                                   <p:childTnLst>
                                     <p:set>
                                       <p:cBhvr>
-                                        <p:cTn id="56" dur="1" fill="hold">
+                                        <p:cTn id="57" dur="1" fill="hold">
                                           <p:stCondLst>
                                             <p:cond delay="0"/>
                                           </p:stCondLst>
@@ -20181,7 +20104,7 @@
                                     </p:set>
                                     <p:animEffect transition="in" filter="fade">
                                       <p:cBhvr>
-                                        <p:cTn id="57" dur="400"/>
+                                        <p:cTn id="58" dur="400"/>
                                         <p:tgtEl>
                                           <p:spTgt spid="22"/>
                                         </p:tgtEl>
@@ -20190,17 +20113,8 @@
                                   </p:childTnLst>
                                 </p:cTn>
                               </p:par>
-                            </p:childTnLst>
-                          </p:cTn>
-                        </p:par>
-                        <p:par>
-                          <p:cTn id="58" fill="hold">
-                            <p:stCondLst>
-                              <p:cond delay="1200"/>
-                            </p:stCondLst>
-                            <p:childTnLst>
                               <p:par>
-                                <p:cTn id="59" presetID="10" presetClass="entr" presetSubtype="0" fill="hold" grpId="0" nodeType="afterEffect">
+                                <p:cTn id="59" presetID="10" presetClass="entr" presetSubtype="0" fill="hold" grpId="0" nodeType="withEffect">
                                   <p:stCondLst>
                                     <p:cond delay="0"/>
                                   </p:stCondLst>
@@ -20298,76 +20212,6 @@
                                         <p:cTn id="67" dur="400"/>
                                         <p:tgtEl>
                                           <p:spTgt spid="25"/>
-                                        </p:tgtEl>
-                                      </p:cBhvr>
-                                    </p:animEffect>
-                                  </p:childTnLst>
-                                </p:cTn>
-                              </p:par>
-                              <p:par>
-                                <p:cTn id="68" presetID="10" presetClass="entr" presetSubtype="0" fill="hold" grpId="0" nodeType="withEffect">
-                                  <p:stCondLst>
-                                    <p:cond delay="0"/>
-                                  </p:stCondLst>
-                                  <p:childTnLst>
-                                    <p:set>
-                                      <p:cBhvr>
-                                        <p:cTn id="69" dur="1" fill="hold">
-                                          <p:stCondLst>
-                                            <p:cond delay="0"/>
-                                          </p:stCondLst>
-                                        </p:cTn>
-                                        <p:tgtEl>
-                                          <p:spTgt spid="26"/>
-                                        </p:tgtEl>
-                                        <p:attrNameLst>
-                                          <p:attrName>style.visibility</p:attrName>
-                                        </p:attrNameLst>
-                                      </p:cBhvr>
-                                      <p:to>
-                                        <p:strVal val="visible"/>
-                                      </p:to>
-                                    </p:set>
-                                    <p:animEffect transition="in" filter="fade">
-                                      <p:cBhvr>
-                                        <p:cTn id="70" dur="400"/>
-                                        <p:tgtEl>
-                                          <p:spTgt spid="26"/>
-                                        </p:tgtEl>
-                                      </p:cBhvr>
-                                    </p:animEffect>
-                                  </p:childTnLst>
-                                </p:cTn>
-                              </p:par>
-                              <p:par>
-                                <p:cTn id="71" presetID="10" presetClass="entr" presetSubtype="0" fill="hold" grpId="0" nodeType="withEffect">
-                                  <p:stCondLst>
-                                    <p:cond delay="0"/>
-                                  </p:stCondLst>
-                                  <p:childTnLst>
-                                    <p:set>
-                                      <p:cBhvr>
-                                        <p:cTn id="72" dur="1" fill="hold">
-                                          <p:stCondLst>
-                                            <p:cond delay="0"/>
-                                          </p:stCondLst>
-                                        </p:cTn>
-                                        <p:tgtEl>
-                                          <p:spTgt spid="27"/>
-                                        </p:tgtEl>
-                                        <p:attrNameLst>
-                                          <p:attrName>style.visibility</p:attrName>
-                                        </p:attrNameLst>
-                                      </p:cBhvr>
-                                      <p:to>
-                                        <p:strVal val="visible"/>
-                                      </p:to>
-                                    </p:set>
-                                    <p:animEffect transition="in" filter="fade">
-                                      <p:cBhvr>
-                                        <p:cTn id="73" dur="400"/>
-                                        <p:tgtEl>
-                                          <p:spTgt spid="27"/>
                                         </p:tgtEl>
                                       </p:cBhvr>
                                     </p:animEffect>
@@ -20418,12 +20262,10 @@
       <p:bldP spid="19" grpId="0"/>
       <p:bldP spid="20" grpId="0"/>
       <p:bldP spid="21" grpId="0" animBg="1"/>
-      <p:bldP spid="22" grpId="0"/>
-      <p:bldP spid="23" grpId="0" animBg="1"/>
-      <p:bldP spid="24" grpId="0" animBg="1"/>
+      <p:bldP spid="22" grpId="0" animBg="1"/>
+      <p:bldP spid="23" grpId="0"/>
+      <p:bldP spid="24" grpId="0"/>
       <p:bldP spid="25" grpId="0"/>
-      <p:bldP spid="26" grpId="0"/>
-      <p:bldP spid="27" grpId="0"/>
     </p:bldLst>
   </p:timing>
 </p:sld>
@@ -20849,7 +20691,7 @@
                 </a:solidFill>
                 <a:latin typeface="Arial"/>
               </a:rPr>
-              <a:t>Answer the open questions</a:t>
+              <a:t>Pick the pilot team</a:t>
             </a:r>
           </a:p>
         </p:txBody>
@@ -20974,7 +20816,7 @@
                 </a:solidFill>
                 <a:latin typeface="Arial"/>
               </a:rPr>
-              <a:t>Start the pilot with one team</a:t>
+              <a:t>Run the pilot with that team</a:t>
             </a:r>
           </a:p>
         </p:txBody>
@@ -24160,7 +24002,7 @@
                 </a:solidFill>
                 <a:latin typeface="Arial"/>
               </a:rPr>
-              <a:t>A cheaper model writes code and tests.</a:t>
+              <a:t>The builder AI writes the code, tests and README.</a:t>
             </a:r>
           </a:p>
         </p:txBody>
@@ -24754,7 +24596,7 @@
                 </a:solidFill>
                 <a:latin typeface="Arial"/>
               </a:rPr>
-              <a:t>Opus plans · cheaper models build</a:t>
+              <a:t>Opus plans and reviews</a:t>
             </a:r>
           </a:p>
         </p:txBody>
@@ -27041,7 +26883,7 @@
                 </a:solidFill>
                 <a:latin typeface="Arial"/>
               </a:rPr>
-              <a:t>A small group. Approve paid resources and releases, decide unsure cases, own the project summaries.</a:t>
+              <a:t>A small group. Approve plans, paid resources and releases, decide unsure cases, own the project summaries. Admins add them in the dashboard.</a:t>
             </a:r>
           </a:p>
         </p:txBody>
@@ -27768,7 +27610,7 @@
                 </a:solidFill>
                 <a:latin typeface="Arial"/>
               </a:rPr>
-              <a:t>No reply in time (e.g. one working day) → next maintainer, everyone told</a:t>
+              <a:t>No reply within 24 hours → next maintainer, everyone told</a:t>
             </a:r>
           </a:p>
         </p:txBody>
@@ -29576,7 +29418,7 @@
                 </a:solidFill>
                 <a:latin typeface="Arial"/>
               </a:rPr>
-              <a:t>Reads links, checks for duplicates, uses project summaries.</a:t>
+              <a:t>Reads links, flags duplicates, uses project summaries.</a:t>
             </a:r>
           </a:p>
         </p:txBody>
@@ -30203,7 +30045,7 @@
                 </a:solidFill>
                 <a:latin typeface="Arial"/>
               </a:rPr>
-              <a:t>Cheaper model, in a sandbox, with tests and a README.</a:t>
+              <a:t>Builder writes code, tests and a README. Running tests in a sandbox is next.</a:t>
             </a:r>
           </a:p>
         </p:txBody>
@@ -30412,7 +30254,7 @@
                 </a:solidFill>
                 <a:latin typeface="Arial"/>
               </a:rPr>
-              <a:t>Opus review, safety check again, human final yes.</a:t>
+              <a:t>Opus review with a safety check, one fix round, human final yes.</a:t>
             </a:r>
           </a:p>
         </p:txBody>
@@ -33338,7 +33180,7 @@
                 </a:solidFill>
                 <a:latin typeface="Arial"/>
               </a:rPr>
-              <a:t>Links open in an isolated sandbox, never on a laptop. The same check runs again on the finished code.</a:t>
+              <a:t>Links are read by a separate process with no secrets, never on a laptop. The review checks the finished code for safety again.</a:t>
             </a:r>
           </a:p>
         </p:txBody>
@@ -35137,7 +34979,7 @@
                 </a:solidFill>
                 <a:latin typeface="Arial"/>
               </a:rPr>
-              <a:t>The bot never creates accounts, enters passwords or spends money. Keys go into a secret store, never into chat.</a:t>
+              <a:t>The bot never creates accounts, enters passwords or spends money. Keys go into the server's secret file, never into chat.</a:t>
             </a:r>
           </a:p>
           <a:p>
@@ -36832,7 +36674,7 @@
                 </a:solidFill>
                 <a:latin typeface="Arial"/>
               </a:rPr>
-              <a:t>The cheaper builder never approves code, and never reviews its own work.</a:t>
+              <a:t>The builder never approves code, and never reviews its own work.</a:t>
             </a:r>
           </a:p>
         </p:txBody>
@@ -38650,7 +38492,7 @@
                 </a:solidFill>
                 <a:latin typeface="Arial"/>
               </a:rPr>
-              <a:t>Testing</a:t>
+              <a:t>Under review</a:t>
             </a:r>
           </a:p>
         </p:txBody>
@@ -38709,137 +38551,6 @@
         <p:spPr>
           <a:xfrm>
             <a:off x="4773168" y="2651760"/>
-            <a:ext cx="1783080" cy="548640"/>
-          </a:xfrm>
-          <a:prstGeom prst="roundRect">
-            <a:avLst>
-              <a:gd name="adj" fmla="val 30000"/>
-            </a:avLst>
-          </a:prstGeom>
-          <a:solidFill>
-            <a:srgbClr val="E0E7FF"/>
-          </a:solidFill>
-          <a:ln>
-            <a:noFill/>
-          </a:ln>
-          <a:effectLst/>
-        </p:spPr>
-        <p:style>
-          <a:lnRef idx="1">
-            <a:schemeClr val="accent1"/>
-          </a:lnRef>
-          <a:fillRef idx="3">
-            <a:schemeClr val="accent1"/>
-          </a:fillRef>
-          <a:effectRef idx="2">
-            <a:schemeClr val="accent1"/>
-          </a:effectRef>
-          <a:fontRef idx="minor">
-            <a:schemeClr val="lt1"/>
-          </a:fontRef>
-        </p:style>
-        <p:txBody>
-          <a:bodyPr rtlCol="0" anchor="ctr"/>
-          <a:lstStyle/>
-          <a:p>
-            <a:pPr algn="ctr"/>
-            <a:endParaRPr/>
-          </a:p>
-        </p:txBody>
-      </p:sp>
-      <p:sp>
-        <p:nvSpPr>
-          <p:cNvPr id="27" name="build02 TextBox 26"/>
-          <p:cNvSpPr txBox="1"/>
-          <p:nvPr/>
-        </p:nvSpPr>
-        <p:spPr>
-          <a:xfrm>
-            <a:off x="4846320" y="2651760"/>
-            <a:ext cx="1636776" cy="548640"/>
-          </a:xfrm>
-          <a:prstGeom prst="rect">
-            <a:avLst/>
-          </a:prstGeom>
-          <a:noFill/>
-        </p:spPr>
-        <p:txBody>
-          <a:bodyPr wrap="square" lIns="0" tIns="0" rIns="0" bIns="0" anchor="ctr">
-            <a:spAutoFit/>
-          </a:bodyPr>
-          <a:lstStyle/>
-          <a:p>
-            <a:pPr algn="ctr">
-              <a:lnSpc>
-                <a:spcPct val="110000"/>
-              </a:lnSpc>
-            </a:pPr>
-            <a:r>
-              <a:rPr sz="1400" b="1" i="0">
-                <a:solidFill>
-                  <a:srgbClr val="4338CA"/>
-                </a:solidFill>
-                <a:latin typeface="Arial"/>
-              </a:rPr>
-              <a:t>Under review</a:t>
-            </a:r>
-          </a:p>
-        </p:txBody>
-      </p:sp>
-      <p:sp>
-        <p:nvSpPr>
-          <p:cNvPr id="28" name="build02 Right Arrow 27"/>
-          <p:cNvSpPr/>
-          <p:nvPr/>
-        </p:nvSpPr>
-        <p:spPr>
-          <a:xfrm>
-            <a:off x="6620256" y="2798064"/>
-            <a:ext cx="237744" cy="256032"/>
-          </a:xfrm>
-          <a:prstGeom prst="rightArrow">
-            <a:avLst/>
-          </a:prstGeom>
-          <a:solidFill>
-            <a:srgbClr val="475569"/>
-          </a:solidFill>
-          <a:ln>
-            <a:noFill/>
-          </a:ln>
-          <a:effectLst/>
-        </p:spPr>
-        <p:style>
-          <a:lnRef idx="1">
-            <a:schemeClr val="accent1"/>
-          </a:lnRef>
-          <a:fillRef idx="3">
-            <a:schemeClr val="accent1"/>
-          </a:fillRef>
-          <a:effectRef idx="2">
-            <a:schemeClr val="accent1"/>
-          </a:effectRef>
-          <a:fontRef idx="minor">
-            <a:schemeClr val="lt1"/>
-          </a:fontRef>
-        </p:style>
-        <p:txBody>
-          <a:bodyPr rtlCol="0" anchor="ctr"/>
-          <a:lstStyle/>
-          <a:p>
-            <a:pPr algn="ctr"/>
-            <a:endParaRPr/>
-          </a:p>
-        </p:txBody>
-      </p:sp>
-      <p:sp>
-        <p:nvSpPr>
-          <p:cNvPr id="29" name="build02 Rounded Rectangle 28"/>
-          <p:cNvSpPr/>
-          <p:nvPr/>
-        </p:nvSpPr>
-        <p:spPr>
-          <a:xfrm>
-            <a:off x="6885432" y="2651760"/>
             <a:ext cx="2377440" cy="548640"/>
           </a:xfrm>
           <a:prstGeom prst="roundRect">
@@ -38880,13 +38591,13 @@
       </p:sp>
       <p:sp>
         <p:nvSpPr>
-          <p:cNvPr id="30" name="build02 TextBox 29"/>
+          <p:cNvPr id="27" name="build02 TextBox 26"/>
           <p:cNvSpPr txBox="1"/>
           <p:nvPr/>
         </p:nvSpPr>
         <p:spPr>
           <a:xfrm>
-            <a:off x="6958584" y="2651760"/>
+            <a:off x="4846320" y="2651760"/>
             <a:ext cx="2231136" cy="548640"/>
           </a:xfrm>
           <a:prstGeom prst="rect">
@@ -38919,7 +38630,7 @@
       </p:sp>
       <p:sp>
         <p:nvSpPr>
-          <p:cNvPr id="31" name="build02 TextBox 30"/>
+          <p:cNvPr id="28" name="build02 TextBox 27"/>
           <p:cNvSpPr txBox="1"/>
           <p:nvPr/>
         </p:nvSpPr>
@@ -38951,14 +38662,14 @@
                 </a:solidFill>
                 <a:latin typeface="Arial"/>
               </a:rPr>
-              <a:t>“Waiting for approval” appears only when a paid resource or login is needed.</a:t>
+              <a:t>“Waiting for approval” appears only when a paid resource or login is needed. A “Testing” stage joins once builds run in a sandbox.</a:t>
             </a:r>
           </a:p>
         </p:txBody>
       </p:sp>
       <p:pic>
         <p:nvPicPr>
-          <p:cNvPr id="32" name="build03 Picture 31" descr="phone.jpg"/>
+          <p:cNvPr id="29" name="build03 Picture 28" descr="phone.jpg"/>
           <p:cNvPicPr>
             <a:picLocks noChangeAspect="1"/>
           </p:cNvPicPr>
@@ -38983,7 +38694,7 @@
       </p:pic>
       <p:sp>
         <p:nvSpPr>
-          <p:cNvPr id="33" name="build03 Rounded Rectangle 32"/>
+          <p:cNvPr id="30" name="build03 Rounded Rectangle 29"/>
           <p:cNvSpPr/>
           <p:nvPr/>
         </p:nvSpPr>
@@ -39030,7 +38741,7 @@
       </p:sp>
       <p:sp>
         <p:nvSpPr>
-          <p:cNvPr id="34" name="build03 Rectangle 33"/>
+          <p:cNvPr id="31" name="build03 Rectangle 30"/>
           <p:cNvSpPr/>
           <p:nvPr/>
         </p:nvSpPr>
@@ -39075,7 +38786,7 @@
       </p:sp>
       <p:sp>
         <p:nvSpPr>
-          <p:cNvPr id="35" name="build03 TextBox 34"/>
+          <p:cNvPr id="32" name="build03 TextBox 31"/>
           <p:cNvSpPr txBox="1"/>
           <p:nvPr/>
         </p:nvSpPr>
@@ -39114,7 +38825,7 @@
       </p:sp>
       <p:sp>
         <p:nvSpPr>
-          <p:cNvPr id="36" name="build03 TextBox 35"/>
+          <p:cNvPr id="33" name="build03 TextBox 32"/>
           <p:cNvSpPr txBox="1"/>
           <p:nvPr/>
         </p:nvSpPr>
@@ -39146,14 +38857,14 @@
                 </a:solidFill>
                 <a:latin typeface="Arial"/>
               </a:rPr>
-              <a:t>Everything goes into the idea's own thread, so anyone can see what happened and why.</a:t>
+              <a:t>Every update goes into the idea's own thread; the maintainer's buttons come in a direct message.</a:t>
             </a:r>
           </a:p>
         </p:txBody>
       </p:sp>
       <p:sp>
         <p:nvSpPr>
-          <p:cNvPr id="37" name="build03 Rounded Rectangle 36"/>
+          <p:cNvPr id="34" name="build03 Rounded Rectangle 33"/>
           <p:cNvSpPr/>
           <p:nvPr/>
         </p:nvSpPr>
@@ -39200,7 +38911,7 @@
       </p:sp>
       <p:sp>
         <p:nvSpPr>
-          <p:cNvPr id="38" name="build03 Rectangle 37"/>
+          <p:cNvPr id="35" name="build03 Rectangle 34"/>
           <p:cNvSpPr/>
           <p:nvPr/>
         </p:nvSpPr>
@@ -39245,7 +38956,7 @@
       </p:sp>
       <p:sp>
         <p:nvSpPr>
-          <p:cNvPr id="39" name="build03 TextBox 38"/>
+          <p:cNvPr id="36" name="build03 TextBox 35"/>
           <p:cNvSpPr txBox="1"/>
           <p:nvPr/>
         </p:nvSpPr>
@@ -39284,7 +38995,7 @@
       </p:sp>
       <p:sp>
         <p:nvSpPr>
-          <p:cNvPr id="40" name="build03 TextBox 39"/>
+          <p:cNvPr id="37" name="build03 TextBox 36"/>
           <p:cNvSpPr txBox="1"/>
           <p:nvPr/>
         </p:nvSpPr>
@@ -40166,15 +39877,24 @@
                                   </p:childTnLst>
                                 </p:cTn>
                               </p:par>
+                            </p:childTnLst>
+                          </p:cTn>
+                        </p:par>
+                        <p:par>
+                          <p:cTn id="75" fill="hold">
+                            <p:stCondLst>
+                              <p:cond delay="800"/>
+                            </p:stCondLst>
+                            <p:childTnLst>
                               <p:par>
-                                <p:cTn id="75" presetID="10" presetClass="entr" presetSubtype="0" fill="hold" grpId="0" nodeType="withEffect">
+                                <p:cTn id="76" presetID="10" presetClass="entr" presetSubtype="0" fill="hold" nodeType="afterEffect">
                                   <p:stCondLst>
                                     <p:cond delay="0"/>
                                   </p:stCondLst>
                                   <p:childTnLst>
                                     <p:set>
                                       <p:cBhvr>
-                                        <p:cTn id="76" dur="1" fill="hold">
+                                        <p:cTn id="77" dur="1" fill="hold">
                                           <p:stCondLst>
                                             <p:cond delay="0"/>
                                           </p:stCondLst>
@@ -40192,7 +39912,7 @@
                                     </p:set>
                                     <p:animEffect transition="in" filter="fade">
                                       <p:cBhvr>
-                                        <p:cTn id="77" dur="400"/>
+                                        <p:cTn id="78" dur="400"/>
                                         <p:tgtEl>
                                           <p:spTgt spid="29"/>
                                         </p:tgtEl>
@@ -40202,14 +39922,14 @@
                                 </p:cTn>
                               </p:par>
                               <p:par>
-                                <p:cTn id="78" presetID="10" presetClass="entr" presetSubtype="0" fill="hold" grpId="0" nodeType="withEffect">
+                                <p:cTn id="79" presetID="10" presetClass="entr" presetSubtype="0" fill="hold" grpId="0" nodeType="withEffect">
                                   <p:stCondLst>
                                     <p:cond delay="0"/>
                                   </p:stCondLst>
                                   <p:childTnLst>
                                     <p:set>
                                       <p:cBhvr>
-                                        <p:cTn id="79" dur="1" fill="hold">
+                                        <p:cTn id="80" dur="1" fill="hold">
                                           <p:stCondLst>
                                             <p:cond delay="0"/>
                                           </p:stCondLst>
@@ -40227,7 +39947,7 @@
                                     </p:set>
                                     <p:animEffect transition="in" filter="fade">
                                       <p:cBhvr>
-                                        <p:cTn id="80" dur="400"/>
+                                        <p:cTn id="81" dur="400"/>
                                         <p:tgtEl>
                                           <p:spTgt spid="30"/>
                                         </p:tgtEl>
@@ -40237,14 +39957,14 @@
                                 </p:cTn>
                               </p:par>
                               <p:par>
-                                <p:cTn id="81" presetID="10" presetClass="entr" presetSubtype="0" fill="hold" grpId="0" nodeType="withEffect">
+                                <p:cTn id="82" presetID="10" presetClass="entr" presetSubtype="0" fill="hold" grpId="0" nodeType="withEffect">
                                   <p:stCondLst>
                                     <p:cond delay="0"/>
                                   </p:stCondLst>
                                   <p:childTnLst>
                                     <p:set>
                                       <p:cBhvr>
-                                        <p:cTn id="82" dur="1" fill="hold">
+                                        <p:cTn id="83" dur="1" fill="hold">
                                           <p:stCondLst>
                                             <p:cond delay="0"/>
                                           </p:stCondLst>
@@ -40262,7 +39982,7 @@
                                     </p:set>
                                     <p:animEffect transition="in" filter="fade">
                                       <p:cBhvr>
-                                        <p:cTn id="83" dur="400"/>
+                                        <p:cTn id="84" dur="400"/>
                                         <p:tgtEl>
                                           <p:spTgt spid="31"/>
                                         </p:tgtEl>
@@ -40271,17 +39991,8 @@
                                   </p:childTnLst>
                                 </p:cTn>
                               </p:par>
-                            </p:childTnLst>
-                          </p:cTn>
-                        </p:par>
-                        <p:par>
-                          <p:cTn id="84" fill="hold">
-                            <p:stCondLst>
-                              <p:cond delay="800"/>
-                            </p:stCondLst>
-                            <p:childTnLst>
                               <p:par>
-                                <p:cTn id="85" presetID="10" presetClass="entr" presetSubtype="0" fill="hold" nodeType="afterEffect">
+                                <p:cTn id="85" presetID="10" presetClass="entr" presetSubtype="0" fill="hold" grpId="0" nodeType="withEffect">
                                   <p:stCondLst>
                                     <p:cond delay="0"/>
                                   </p:stCondLst>
@@ -40484,111 +40195,6 @@
                                         <p:cTn id="102" dur="400"/>
                                         <p:tgtEl>
                                           <p:spTgt spid="37"/>
-                                        </p:tgtEl>
-                                      </p:cBhvr>
-                                    </p:animEffect>
-                                  </p:childTnLst>
-                                </p:cTn>
-                              </p:par>
-                              <p:par>
-                                <p:cTn id="103" presetID="10" presetClass="entr" presetSubtype="0" fill="hold" grpId="0" nodeType="withEffect">
-                                  <p:stCondLst>
-                                    <p:cond delay="0"/>
-                                  </p:stCondLst>
-                                  <p:childTnLst>
-                                    <p:set>
-                                      <p:cBhvr>
-                                        <p:cTn id="104" dur="1" fill="hold">
-                                          <p:stCondLst>
-                                            <p:cond delay="0"/>
-                                          </p:stCondLst>
-                                        </p:cTn>
-                                        <p:tgtEl>
-                                          <p:spTgt spid="38"/>
-                                        </p:tgtEl>
-                                        <p:attrNameLst>
-                                          <p:attrName>style.visibility</p:attrName>
-                                        </p:attrNameLst>
-                                      </p:cBhvr>
-                                      <p:to>
-                                        <p:strVal val="visible"/>
-                                      </p:to>
-                                    </p:set>
-                                    <p:animEffect transition="in" filter="fade">
-                                      <p:cBhvr>
-                                        <p:cTn id="105" dur="400"/>
-                                        <p:tgtEl>
-                                          <p:spTgt spid="38"/>
-                                        </p:tgtEl>
-                                      </p:cBhvr>
-                                    </p:animEffect>
-                                  </p:childTnLst>
-                                </p:cTn>
-                              </p:par>
-                              <p:par>
-                                <p:cTn id="106" presetID="10" presetClass="entr" presetSubtype="0" fill="hold" grpId="0" nodeType="withEffect">
-                                  <p:stCondLst>
-                                    <p:cond delay="0"/>
-                                  </p:stCondLst>
-                                  <p:childTnLst>
-                                    <p:set>
-                                      <p:cBhvr>
-                                        <p:cTn id="107" dur="1" fill="hold">
-                                          <p:stCondLst>
-                                            <p:cond delay="0"/>
-                                          </p:stCondLst>
-                                        </p:cTn>
-                                        <p:tgtEl>
-                                          <p:spTgt spid="39"/>
-                                        </p:tgtEl>
-                                        <p:attrNameLst>
-                                          <p:attrName>style.visibility</p:attrName>
-                                        </p:attrNameLst>
-                                      </p:cBhvr>
-                                      <p:to>
-                                        <p:strVal val="visible"/>
-                                      </p:to>
-                                    </p:set>
-                                    <p:animEffect transition="in" filter="fade">
-                                      <p:cBhvr>
-                                        <p:cTn id="108" dur="400"/>
-                                        <p:tgtEl>
-                                          <p:spTgt spid="39"/>
-                                        </p:tgtEl>
-                                      </p:cBhvr>
-                                    </p:animEffect>
-                                  </p:childTnLst>
-                                </p:cTn>
-                              </p:par>
-                              <p:par>
-                                <p:cTn id="109" presetID="10" presetClass="entr" presetSubtype="0" fill="hold" grpId="0" nodeType="withEffect">
-                                  <p:stCondLst>
-                                    <p:cond delay="0"/>
-                                  </p:stCondLst>
-                                  <p:childTnLst>
-                                    <p:set>
-                                      <p:cBhvr>
-                                        <p:cTn id="110" dur="1" fill="hold">
-                                          <p:stCondLst>
-                                            <p:cond delay="0"/>
-                                          </p:stCondLst>
-                                        </p:cTn>
-                                        <p:tgtEl>
-                                          <p:spTgt spid="40"/>
-                                        </p:tgtEl>
-                                        <p:attrNameLst>
-                                          <p:attrName>style.visibility</p:attrName>
-                                        </p:attrNameLst>
-                                      </p:cBhvr>
-                                      <p:to>
-                                        <p:strVal val="visible"/>
-                                      </p:to>
-                                    </p:set>
-                                    <p:animEffect transition="in" filter="fade">
-                                      <p:cBhvr>
-                                        <p:cTn id="111" dur="400"/>
-                                        <p:tgtEl>
-                                          <p:spTgt spid="40"/>
                                         </p:tgtEl>
                                       </p:cBhvr>
                                     </p:animEffect>
@@ -40645,18 +40251,15 @@
       <p:bldP spid="25" grpId="0" animBg="1"/>
       <p:bldP spid="26" grpId="0" animBg="1"/>
       <p:bldP spid="27" grpId="0"/>
-      <p:bldP spid="28" grpId="0" animBg="1"/>
-      <p:bldP spid="29" grpId="0" animBg="1"/>
-      <p:bldP spid="30" grpId="0"/>
-      <p:bldP spid="31" grpId="0"/>
-      <p:bldP spid="33" grpId="0" animBg="1"/>
+      <p:bldP spid="28" grpId="0"/>
+      <p:bldP spid="30" grpId="0" animBg="1"/>
+      <p:bldP spid="31" grpId="0" animBg="1"/>
+      <p:bldP spid="32" grpId="0"/>
+      <p:bldP spid="33" grpId="0"/>
       <p:bldP spid="34" grpId="0" animBg="1"/>
-      <p:bldP spid="35" grpId="0"/>
+      <p:bldP spid="35" grpId="0" animBg="1"/>
       <p:bldP spid="36" grpId="0"/>
-      <p:bldP spid="37" grpId="0" animBg="1"/>
-      <p:bldP spid="38" grpId="0" animBg="1"/>
-      <p:bldP spid="39" grpId="0"/>
-      <p:bldP spid="40" grpId="0"/>
+      <p:bldP spid="37" grpId="0"/>
     </p:bldLst>
   </p:timing>
 </p:sld>

</xml_diff>

<commit_message>
Rollout: the install command is built
Co-Authored-By: Claude Opus 5.5 <noreply@anthropic.com>
</commit_message>
<xml_diff>
--- a/DevExAI.pptx
+++ b/DevExAI.pptx
@@ -169,7 +169,7 @@
     </p:spTree>
     <p:extLst>
       <p:ext uri="{BB962C8B-B14F-4D97-AF65-F5344CB8AC3E}">
-        <p14:creationId xmlns:p14="http://schemas.microsoft.com/office/powerpoint/2010/main" val="1857724115"/>
+        <p14:creationId xmlns:p14="http://schemas.microsoft.com/office/powerpoint/2010/main" val="1529526948"/>
       </p:ext>
     </p:extLst>
   </p:cSld>
@@ -14844,7 +14844,7 @@
                 </a:solidFill>
                 <a:latin typeface="Arial"/>
               </a:rPr>
-              <a:t>Built: builder, Opus review, auto post. Next: tests in a sandbox, install command, account pool.</a:t>
+              <a:t>Built: builder, Opus review, auto post, install command. Next: tests in a sandbox, account pool.</a:t>
             </a:r>
           </a:p>
         </p:txBody>

</xml_diff>

<commit_message>
Deck: install slide matches devex.py
Co-Authored-By: Claude Opus 5.5 <noreply@anthropic.com>
</commit_message>
<xml_diff>
--- a/DevExAI.pptx
+++ b/DevExAI.pptx
@@ -169,7 +169,7 @@
     </p:spTree>
     <p:extLst>
       <p:ext uri="{BB962C8B-B14F-4D97-AF65-F5344CB8AC3E}">
-        <p14:creationId xmlns:p14="http://schemas.microsoft.com/office/powerpoint/2010/main" val="1529526948"/>
+        <p14:creationId xmlns:p14="http://schemas.microsoft.com/office/powerpoint/2010/main" val="175197319"/>
       </p:ext>
     </p:extLst>
   </p:cSld>
@@ -6950,13 +6950,13 @@
               </a:lnSpc>
             </a:pPr>
             <a:r>
-              <a:rPr sz="1600" b="1" i="0">
+              <a:rPr sz="1400" b="1" i="0">
                 <a:solidFill>
                   <a:srgbClr val="FFFFFF"/>
                 </a:solidFill>
                 <a:latin typeface="Courier New"/>
               </a:rPr>
-              <a:t>devex install &lt;tool&gt; --project</a:t>
+              <a:t>python devex.py install &lt;tool&gt; --project</a:t>
             </a:r>
           </a:p>
         </p:txBody>
@@ -6995,7 +6995,7 @@
                 </a:solidFill>
                 <a:latin typeface="Arial"/>
               </a:rPr>
-              <a:t>Files go into the project's folder (.claude/, .gemini/, .codex/) and can be committed, so the whole team gets it.</a:t>
+              <a:t>The tool's files go into the project's .claude/, .gemini/ and .codex/ folders and can be committed, so the whole team gets it.</a:t>
             </a:r>
           </a:p>
         </p:txBody>
@@ -7209,13 +7209,13 @@
               </a:lnSpc>
             </a:pPr>
             <a:r>
-              <a:rPr sz="1600" b="1" i="0">
+              <a:rPr sz="1400" b="1" i="0">
                 <a:solidFill>
                   <a:srgbClr val="FFFFFF"/>
                 </a:solidFill>
                 <a:latin typeface="Courier New"/>
               </a:rPr>
-              <a:t>devex install &lt;tool&gt; --global</a:t>
+              <a:t>python devex.py install &lt;tool&gt; --global</a:t>
             </a:r>
           </a:p>
         </p:txBody>
@@ -7254,7 +7254,7 @@
                 </a:solidFill>
                 <a:latin typeface="Arial"/>
               </a:rPr>
-              <a:t>Files go into your personal settings folder and work in every project.</a:t>
+              <a:t>The same files go into those folders in your home folder and work in every project.</a:t>
             </a:r>
           </a:p>
         </p:txBody>
@@ -7315,8 +7315,8 @@
         </p:nvSpPr>
         <p:spPr>
           <a:xfrm>
-            <a:off x="548640" y="5212080"/>
-            <a:ext cx="5364327" cy="594360"/>
+            <a:off x="548640" y="5120640"/>
+            <a:ext cx="3515258" cy="594360"/>
           </a:xfrm>
           <a:prstGeom prst="roundRect">
             <a:avLst>
@@ -7362,8 +7362,8 @@
         </p:nvSpPr>
         <p:spPr>
           <a:xfrm>
-            <a:off x="621792" y="5212080"/>
-            <a:ext cx="5218023" cy="594360"/>
+            <a:off x="621792" y="5120640"/>
+            <a:ext cx="3368954" cy="594360"/>
           </a:xfrm>
           <a:prstGeom prst="rect">
             <a:avLst/>
@@ -7388,7 +7388,7 @@
                 </a:solidFill>
                 <a:latin typeface="Arial"/>
               </a:rPr>
-              <a:t>Shows exactly what it will change first</a:t>
+              <a:t>Shows each change, asks first</a:t>
             </a:r>
           </a:p>
         </p:txBody>
@@ -7401,8 +7401,8 @@
         </p:nvSpPr>
         <p:spPr>
           <a:xfrm>
-            <a:off x="6278727" y="5212080"/>
-            <a:ext cx="5364327" cy="594360"/>
+            <a:off x="4338218" y="5120640"/>
+            <a:ext cx="3515258" cy="594360"/>
           </a:xfrm>
           <a:prstGeom prst="roundRect">
             <a:avLst>
@@ -7448,8 +7448,8 @@
         </p:nvSpPr>
         <p:spPr>
           <a:xfrm>
-            <a:off x="6351879" y="5212080"/>
-            <a:ext cx="5218023" cy="594360"/>
+            <a:off x="4411370" y="5120640"/>
+            <a:ext cx="3368954" cy="594360"/>
           </a:xfrm>
           <a:prstGeom prst="rect">
             <a:avLst/>
@@ -7474,7 +7474,132 @@
                 </a:solidFill>
                 <a:latin typeface="Arial"/>
               </a:rPr>
-              <a:t>devex uninstall removes it cleanly</a:t>
+              <a:t>Never runs the tool's code</a:t>
+            </a:r>
+          </a:p>
+        </p:txBody>
+      </p:sp>
+      <p:sp>
+        <p:nvSpPr>
+          <p:cNvPr id="22" name="build03 Rounded Rectangle 21"/>
+          <p:cNvSpPr/>
+          <p:nvPr/>
+        </p:nvSpPr>
+        <p:spPr>
+          <a:xfrm>
+            <a:off x="8127796" y="5120640"/>
+            <a:ext cx="3515258" cy="594360"/>
+          </a:xfrm>
+          <a:prstGeom prst="roundRect">
+            <a:avLst>
+              <a:gd name="adj" fmla="val 30000"/>
+            </a:avLst>
+          </a:prstGeom>
+          <a:solidFill>
+            <a:srgbClr val="CCFBF1"/>
+          </a:solidFill>
+          <a:ln>
+            <a:noFill/>
+          </a:ln>
+          <a:effectLst/>
+        </p:spPr>
+        <p:style>
+          <a:lnRef idx="1">
+            <a:schemeClr val="accent1"/>
+          </a:lnRef>
+          <a:fillRef idx="3">
+            <a:schemeClr val="accent1"/>
+          </a:fillRef>
+          <a:effectRef idx="2">
+            <a:schemeClr val="accent1"/>
+          </a:effectRef>
+          <a:fontRef idx="minor">
+            <a:schemeClr val="lt1"/>
+          </a:fontRef>
+        </p:style>
+        <p:txBody>
+          <a:bodyPr rtlCol="0" anchor="ctr"/>
+          <a:lstStyle/>
+          <a:p>
+            <a:pPr algn="ctr"/>
+            <a:endParaRPr/>
+          </a:p>
+        </p:txBody>
+      </p:sp>
+      <p:sp>
+        <p:nvSpPr>
+          <p:cNvPr id="23" name="build03 TextBox 22"/>
+          <p:cNvSpPr txBox="1"/>
+          <p:nvPr/>
+        </p:nvSpPr>
+        <p:spPr>
+          <a:xfrm>
+            <a:off x="8200948" y="5120640"/>
+            <a:ext cx="3368954" cy="594360"/>
+          </a:xfrm>
+          <a:prstGeom prst="rect">
+            <a:avLst/>
+          </a:prstGeom>
+          <a:noFill/>
+        </p:spPr>
+        <p:txBody>
+          <a:bodyPr wrap="square" lIns="0" tIns="0" rIns="0" bIns="0" anchor="ctr">
+            <a:spAutoFit/>
+          </a:bodyPr>
+          <a:lstStyle/>
+          <a:p>
+            <a:pPr algn="ctr">
+              <a:lnSpc>
+                <a:spcPct val="110000"/>
+              </a:lnSpc>
+            </a:pPr>
+            <a:r>
+              <a:rPr sz="1600" b="1" i="0">
+                <a:solidFill>
+                  <a:srgbClr val="0F766E"/>
+                </a:solidFill>
+                <a:latin typeface="Arial"/>
+              </a:rPr>
+              <a:t>Uninstall keeps your edits</a:t>
+            </a:r>
+          </a:p>
+        </p:txBody>
+      </p:sp>
+      <p:sp>
+        <p:nvSpPr>
+          <p:cNvPr id="24" name="build03 TextBox 23"/>
+          <p:cNvSpPr txBox="1"/>
+          <p:nvPr/>
+        </p:nvSpPr>
+        <p:spPr>
+          <a:xfrm>
+            <a:off x="548640" y="5852160"/>
+            <a:ext cx="11094415" cy="411480"/>
+          </a:xfrm>
+          <a:prstGeom prst="rect">
+            <a:avLst/>
+          </a:prstGeom>
+          <a:noFill/>
+        </p:spPr>
+        <p:txBody>
+          <a:bodyPr wrap="square" lIns="0" tIns="0" rIns="0" bIns="0" anchor="t">
+            <a:spAutoFit/>
+          </a:bodyPr>
+          <a:lstStyle/>
+          <a:p>
+            <a:pPr algn="l">
+              <a:lnSpc>
+                <a:spcPct val="110000"/>
+              </a:lnSpc>
+            </a:pPr>
+            <a:r>
+              <a:rPr sz="1400" b="0" i="0">
+                <a:solidFill>
+                  <a:srgbClr val="475569"/>
+                </a:solidFill>
+                <a:latin typeface="Arial"/>
+              </a:rPr>
+              <a:t>devex.py is one Python file from /blog/devex.py. It never edits settings files, and never overwrites other files without --force.</a:t>
             </a:r>
           </a:p>
         </p:txBody>
@@ -8082,6 +8207,111 @@
                                         <p:cTn id="54" dur="400"/>
                                         <p:tgtEl>
                                           <p:spTgt spid="21"/>
+                                        </p:tgtEl>
+                                      </p:cBhvr>
+                                    </p:animEffect>
+                                  </p:childTnLst>
+                                </p:cTn>
+                              </p:par>
+                              <p:par>
+                                <p:cTn id="55" presetID="10" presetClass="entr" presetSubtype="0" fill="hold" grpId="0" nodeType="withEffect">
+                                  <p:stCondLst>
+                                    <p:cond delay="0"/>
+                                  </p:stCondLst>
+                                  <p:childTnLst>
+                                    <p:set>
+                                      <p:cBhvr>
+                                        <p:cTn id="56" dur="1" fill="hold">
+                                          <p:stCondLst>
+                                            <p:cond delay="0"/>
+                                          </p:stCondLst>
+                                        </p:cTn>
+                                        <p:tgtEl>
+                                          <p:spTgt spid="22"/>
+                                        </p:tgtEl>
+                                        <p:attrNameLst>
+                                          <p:attrName>style.visibility</p:attrName>
+                                        </p:attrNameLst>
+                                      </p:cBhvr>
+                                      <p:to>
+                                        <p:strVal val="visible"/>
+                                      </p:to>
+                                    </p:set>
+                                    <p:animEffect transition="in" filter="fade">
+                                      <p:cBhvr>
+                                        <p:cTn id="57" dur="400"/>
+                                        <p:tgtEl>
+                                          <p:spTgt spid="22"/>
+                                        </p:tgtEl>
+                                      </p:cBhvr>
+                                    </p:animEffect>
+                                  </p:childTnLst>
+                                </p:cTn>
+                              </p:par>
+                              <p:par>
+                                <p:cTn id="58" presetID="10" presetClass="entr" presetSubtype="0" fill="hold" grpId="0" nodeType="withEffect">
+                                  <p:stCondLst>
+                                    <p:cond delay="0"/>
+                                  </p:stCondLst>
+                                  <p:childTnLst>
+                                    <p:set>
+                                      <p:cBhvr>
+                                        <p:cTn id="59" dur="1" fill="hold">
+                                          <p:stCondLst>
+                                            <p:cond delay="0"/>
+                                          </p:stCondLst>
+                                        </p:cTn>
+                                        <p:tgtEl>
+                                          <p:spTgt spid="23"/>
+                                        </p:tgtEl>
+                                        <p:attrNameLst>
+                                          <p:attrName>style.visibility</p:attrName>
+                                        </p:attrNameLst>
+                                      </p:cBhvr>
+                                      <p:to>
+                                        <p:strVal val="visible"/>
+                                      </p:to>
+                                    </p:set>
+                                    <p:animEffect transition="in" filter="fade">
+                                      <p:cBhvr>
+                                        <p:cTn id="60" dur="400"/>
+                                        <p:tgtEl>
+                                          <p:spTgt spid="23"/>
+                                        </p:tgtEl>
+                                      </p:cBhvr>
+                                    </p:animEffect>
+                                  </p:childTnLst>
+                                </p:cTn>
+                              </p:par>
+                              <p:par>
+                                <p:cTn id="61" presetID="10" presetClass="entr" presetSubtype="0" fill="hold" grpId="0" nodeType="withEffect">
+                                  <p:stCondLst>
+                                    <p:cond delay="0"/>
+                                  </p:stCondLst>
+                                  <p:childTnLst>
+                                    <p:set>
+                                      <p:cBhvr>
+                                        <p:cTn id="62" dur="1" fill="hold">
+                                          <p:stCondLst>
+                                            <p:cond delay="0"/>
+                                          </p:stCondLst>
+                                        </p:cTn>
+                                        <p:tgtEl>
+                                          <p:spTgt spid="24"/>
+                                        </p:tgtEl>
+                                        <p:attrNameLst>
+                                          <p:attrName>style.visibility</p:attrName>
+                                        </p:attrNameLst>
+                                      </p:cBhvr>
+                                      <p:to>
+                                        <p:strVal val="visible"/>
+                                      </p:to>
+                                    </p:set>
+                                    <p:animEffect transition="in" filter="fade">
+                                      <p:cBhvr>
+                                        <p:cTn id="63" dur="400"/>
+                                        <p:tgtEl>
+                                          <p:spTgt spid="24"/>
                                         </p:tgtEl>
                                       </p:cBhvr>
                                     </p:animEffect>
@@ -8132,6 +8362,9 @@
       <p:bldP spid="19" grpId="0"/>
       <p:bldP spid="20" grpId="0" animBg="1"/>
       <p:bldP spid="21" grpId="0"/>
+      <p:bldP spid="22" grpId="0" animBg="1"/>
+      <p:bldP spid="23" grpId="0"/>
+      <p:bldP spid="24" grpId="0"/>
     </p:bldLst>
   </p:timing>
 </p:sld>

</xml_diff>

<commit_message>
Deck: install slide shows the setups and devexai install
Co-Authored-By: Claude Opus 5.5 <noreply@anthropic.com>
</commit_message>
<xml_diff>
--- a/DevExAI.pptx
+++ b/DevExAI.pptx
@@ -169,7 +169,7 @@
     </p:spTree>
     <p:extLst>
       <p:ext uri="{BB962C8B-B14F-4D97-AF65-F5344CB8AC3E}">
-        <p14:creationId xmlns:p14="http://schemas.microsoft.com/office/powerpoint/2010/main" val="175197319"/>
+        <p14:creationId xmlns:p14="http://schemas.microsoft.com/office/powerpoint/2010/main" val="2267641224"/>
       </p:ext>
     </p:extLst>
   </p:cSld>
@@ -6706,7 +6706,7 @@
                 </a:solidFill>
                 <a:latin typeface="Arial"/>
               </a:rPr>
-              <a:t>Your project or your whole machine — your choice</a:t>
+              <a:t>Set up each computer once, then one command per tool</a:t>
             </a:r>
           </a:p>
         </p:txBody>
@@ -6798,7 +6798,7 @@
         <p:spPr>
           <a:xfrm>
             <a:off x="548640" y="1600200"/>
-            <a:ext cx="5364327" cy="3291840"/>
+            <a:ext cx="3515258" cy="2880360"/>
           </a:xfrm>
           <a:prstGeom prst="roundRect">
             <a:avLst>
@@ -6844,8 +6844,8 @@
         </p:nvSpPr>
         <p:spPr>
           <a:xfrm>
-            <a:off x="868680" y="1783080"/>
-            <a:ext cx="4724247" cy="457200"/>
+            <a:off x="822959" y="1783080"/>
+            <a:ext cx="2966618" cy="411480"/>
           </a:xfrm>
           <a:prstGeom prst="rect">
             <a:avLst/>
@@ -6864,13 +6864,13 @@
               </a:lnSpc>
             </a:pPr>
             <a:r>
-              <a:rPr sz="2200" b="1" i="0">
+              <a:rPr sz="2000" b="1" i="0">
                 <a:solidFill>
                   <a:srgbClr val="0F172A"/>
                 </a:solidFill>
                 <a:latin typeface="Arial"/>
               </a:rPr>
-              <a:t>This project only</a:t>
+              <a:t>The admin, on the host</a:t>
             </a:r>
           </a:p>
         </p:txBody>
@@ -6883,8 +6883,8 @@
         </p:nvSpPr>
         <p:spPr>
           <a:xfrm>
-            <a:off x="868680" y="2377440"/>
-            <a:ext cx="4724247" cy="548640"/>
+            <a:off x="822959" y="2331720"/>
+            <a:ext cx="2966618" cy="502920"/>
           </a:xfrm>
           <a:prstGeom prst="roundRect">
             <a:avLst>
@@ -6930,8 +6930,8 @@
         </p:nvSpPr>
         <p:spPr>
           <a:xfrm>
-            <a:off x="1051560" y="2377440"/>
-            <a:ext cx="4358487" cy="548640"/>
+            <a:off x="960120" y="2331720"/>
+            <a:ext cx="2692298" cy="502920"/>
           </a:xfrm>
           <a:prstGeom prst="rect">
             <a:avLst/>
@@ -6956,7 +6956,7 @@
                 </a:solidFill>
                 <a:latin typeface="Courier New"/>
               </a:rPr>
-              <a:t>python devex.py install &lt;tool&gt; --project</a:t>
+              <a:t>DevExAI-Admin-Setup.exe</a:t>
             </a:r>
           </a:p>
         </p:txBody>
@@ -6969,8 +6969,8 @@
         </p:nvSpPr>
         <p:spPr>
           <a:xfrm>
-            <a:off x="868680" y="3108960"/>
-            <a:ext cx="4724247" cy="1005840"/>
+            <a:off x="822959" y="2971800"/>
+            <a:ext cx="2966618" cy="1463040"/>
           </a:xfrm>
           <a:prstGeom prst="rect">
             <a:avLst/>
@@ -6989,75 +6989,45 @@
               </a:lnSpc>
             </a:pPr>
             <a:r>
-              <a:rPr sz="1600" b="0" i="0">
+              <a:rPr sz="1400" b="0" i="0">
                 <a:solidFill>
                   <a:srgbClr val="1E293B"/>
                 </a:solidFill>
                 <a:latin typeface="Arial"/>
               </a:rPr>
-              <a:t>The tool's files go into the project's .claude/, .gemini/ and .codex/ folders and can be committed, so the whole team gets it.</a:t>
-            </a:r>
-          </a:p>
-        </p:txBody>
-      </p:sp>
-      <p:sp>
-        <p:nvSpPr>
-          <p:cNvPr id="11" name="build01 TextBox 10"/>
-          <p:cNvSpPr txBox="1"/>
-          <p:nvPr/>
-        </p:nvSpPr>
-        <p:spPr>
-          <a:xfrm>
-            <a:off x="868680" y="4251960"/>
-            <a:ext cx="4724247" cy="457200"/>
-          </a:xfrm>
-          <a:prstGeom prst="rect">
-            <a:avLst/>
-          </a:prstGeom>
-          <a:noFill/>
-        </p:spPr>
-        <p:txBody>
-          <a:bodyPr wrap="square" lIns="0" tIns="0" rIns="0" bIns="0" anchor="t">
-            <a:spAutoFit/>
-          </a:bodyPr>
-          <a:lstStyle/>
-          <a:p>
-            <a:pPr algn="l">
-              <a:lnSpc>
-                <a:spcPct val="110000"/>
-              </a:lnSpc>
-            </a:pPr>
-            <a:r>
-              <a:rPr sz="1600" b="1" i="0">
-                <a:solidFill>
-                  <a:srgbClr val="4338CA"/>
-                </a:solidFill>
-                <a:latin typeface="Arial"/>
-              </a:rPr>
-              <a:t>Good for: </a:t>
+              <a:t>No admin rights needed. </a:t>
             </a:r>
             <a:r>
-              <a:rPr sz="1600" b="0" i="0">
+              <a:rPr sz="1400" b="1" i="0">
+                <a:solidFill>
+                  <a:srgbClr val="0F172A"/>
+                </a:solidFill>
+                <a:latin typeface="Courier New"/>
+              </a:rPr>
+              <a:t>devexai start admin</a:t>
+            </a:r>
+            <a:r>
+              <a:rPr sz="1400" b="0" i="0">
                 <a:solidFill>
                   <a:srgbClr val="1E293B"/>
                 </a:solidFill>
                 <a:latin typeface="Arial"/>
               </a:rPr>
-              <a:t>Team or project tools</a:t>
+              <a:t> starts the bot and dashboard in the background and opens it; run again, it only opens the dashboard.</a:t>
             </a:r>
           </a:p>
         </p:txBody>
       </p:sp>
       <p:sp>
         <p:nvSpPr>
-          <p:cNvPr id="12" name="build02 Rounded Rectangle 11"/>
+          <p:cNvPr id="11" name="build02 Rounded Rectangle 10"/>
           <p:cNvSpPr/>
           <p:nvPr/>
         </p:nvSpPr>
         <p:spPr>
           <a:xfrm>
-            <a:off x="6278727" y="1600200"/>
-            <a:ext cx="5364327" cy="3291840"/>
+            <a:off x="4338218" y="1600200"/>
+            <a:ext cx="3515258" cy="2880360"/>
           </a:xfrm>
           <a:prstGeom prst="roundRect">
             <a:avLst>
@@ -7097,14 +7067,14 @@
       </p:sp>
       <p:sp>
         <p:nvSpPr>
-          <p:cNvPr id="13" name="build02 TextBox 12"/>
+          <p:cNvPr id="12" name="build02 TextBox 11"/>
           <p:cNvSpPr txBox="1"/>
           <p:nvPr/>
         </p:nvSpPr>
         <p:spPr>
           <a:xfrm>
-            <a:off x="6598767" y="1783080"/>
-            <a:ext cx="4724247" cy="457200"/>
+            <a:off x="4612538" y="1783080"/>
+            <a:ext cx="2966618" cy="411480"/>
           </a:xfrm>
           <a:prstGeom prst="rect">
             <a:avLst/>
@@ -7123,27 +7093,27 @@
               </a:lnSpc>
             </a:pPr>
             <a:r>
-              <a:rPr sz="2200" b="1" i="0">
+              <a:rPr sz="2000" b="1" i="0">
                 <a:solidFill>
                   <a:srgbClr val="0F172A"/>
                 </a:solidFill>
                 <a:latin typeface="Arial"/>
               </a:rPr>
-              <a:t>My whole machine</a:t>
+              <a:t>Each developer, once</a:t>
             </a:r>
           </a:p>
         </p:txBody>
       </p:sp>
       <p:sp>
         <p:nvSpPr>
-          <p:cNvPr id="14" name="build02 Rounded Rectangle 13"/>
+          <p:cNvPr id="13" name="build02 Rounded Rectangle 12"/>
           <p:cNvSpPr/>
           <p:nvPr/>
         </p:nvSpPr>
         <p:spPr>
           <a:xfrm>
-            <a:off x="6598767" y="2377440"/>
-            <a:ext cx="4724247" cy="548640"/>
+            <a:off x="4612538" y="2331720"/>
+            <a:ext cx="2966618" cy="502920"/>
           </a:xfrm>
           <a:prstGeom prst="roundRect">
             <a:avLst>
@@ -7183,14 +7153,14 @@
       </p:sp>
       <p:sp>
         <p:nvSpPr>
-          <p:cNvPr id="15" name="build02 TextBox 14"/>
+          <p:cNvPr id="14" name="build02 TextBox 13"/>
           <p:cNvSpPr txBox="1"/>
           <p:nvPr/>
         </p:nvSpPr>
         <p:spPr>
           <a:xfrm>
-            <a:off x="6781647" y="2377440"/>
-            <a:ext cx="4358487" cy="548640"/>
+            <a:off x="4749698" y="2331720"/>
+            <a:ext cx="2692298" cy="502920"/>
           </a:xfrm>
           <a:prstGeom prst="rect">
             <a:avLst/>
@@ -7215,21 +7185,21 @@
                 </a:solidFill>
                 <a:latin typeface="Courier New"/>
               </a:rPr>
-              <a:t>python devex.py install &lt;tool&gt; --global</a:t>
+              <a:t>DevExAI-User-Setup.exe</a:t>
             </a:r>
           </a:p>
         </p:txBody>
       </p:sp>
       <p:sp>
         <p:nvSpPr>
-          <p:cNvPr id="16" name="build02 TextBox 15"/>
+          <p:cNvPr id="15" name="build02 TextBox 14"/>
           <p:cNvSpPr txBox="1"/>
           <p:nvPr/>
         </p:nvSpPr>
         <p:spPr>
           <a:xfrm>
-            <a:off x="6598767" y="3108960"/>
-            <a:ext cx="4724247" cy="1005840"/>
+            <a:off x="4612538" y="2971800"/>
+            <a:ext cx="2966618" cy="1463040"/>
           </a:xfrm>
           <a:prstGeom prst="rect">
             <a:avLst/>
@@ -7248,27 +7218,111 @@
               </a:lnSpc>
             </a:pPr>
             <a:r>
-              <a:rPr sz="1600" b="0" i="0">
+              <a:rPr sz="1400" b="0" i="0">
                 <a:solidFill>
                   <a:srgbClr val="1E293B"/>
                 </a:solidFill>
                 <a:latin typeface="Arial"/>
               </a:rPr>
-              <a:t>The same files go into those folders in your home folder and work in every project.</a:t>
+              <a:t>From the dashboard's /get page. Asks for the server, trusts the company CA, puts </a:t>
             </a:r>
-          </a:p>
-        </p:txBody>
-      </p:sp>
-      <p:sp>
-        <p:nvSpPr>
-          <p:cNvPr id="17" name="build02 TextBox 16"/>
+            <a:r>
+              <a:rPr sz="1400" b="1" i="0">
+                <a:solidFill>
+                  <a:srgbClr val="0F172A"/>
+                </a:solidFill>
+                <a:latin typeface="Courier New"/>
+              </a:rPr>
+              <a:t>devexai</a:t>
+            </a:r>
+            <a:r>
+              <a:rPr sz="1400" b="0" i="0">
+                <a:solidFill>
+                  <a:srgbClr val="1E293B"/>
+                </a:solidFill>
+                <a:latin typeface="Arial"/>
+              </a:rPr>
+              <a:t> on PATH. No admin code inside.</a:t>
+            </a:r>
+          </a:p>
+          <a:p>
+            <a:pPr algn="l">
+              <a:lnSpc>
+                <a:spcPct val="110000"/>
+              </a:lnSpc>
+              <a:spcBef>
+                <a:spcPts val="600"/>
+              </a:spcBef>
+            </a:pPr>
+            <a:r>
+              <a:rPr sz="1400" b="0" i="0">
+                <a:solidFill>
+                  <a:srgbClr val="1E293B"/>
+                </a:solidFill>
+                <a:latin typeface="Arial"/>
+              </a:rPr>
+              <a:t>Linux: one curl | sh line from the same page.</a:t>
+            </a:r>
+          </a:p>
+        </p:txBody>
+      </p:sp>
+      <p:sp>
+        <p:nvSpPr>
+          <p:cNvPr id="16" name="build03 Rounded Rectangle 15"/>
+          <p:cNvSpPr/>
+          <p:nvPr/>
+        </p:nvSpPr>
+        <p:spPr>
+          <a:xfrm>
+            <a:off x="8127796" y="1600200"/>
+            <a:ext cx="3515258" cy="2880360"/>
+          </a:xfrm>
+          <a:prstGeom prst="roundRect">
+            <a:avLst>
+              <a:gd name="adj" fmla="val 6000"/>
+            </a:avLst>
+          </a:prstGeom>
+          <a:solidFill>
+            <a:srgbClr val="F1F5F9"/>
+          </a:solidFill>
+          <a:ln>
+            <a:noFill/>
+          </a:ln>
+          <a:effectLst/>
+        </p:spPr>
+        <p:style>
+          <a:lnRef idx="1">
+            <a:schemeClr val="accent1"/>
+          </a:lnRef>
+          <a:fillRef idx="3">
+            <a:schemeClr val="accent1"/>
+          </a:fillRef>
+          <a:effectRef idx="2">
+            <a:schemeClr val="accent1"/>
+          </a:effectRef>
+          <a:fontRef idx="minor">
+            <a:schemeClr val="lt1"/>
+          </a:fontRef>
+        </p:style>
+        <p:txBody>
+          <a:bodyPr rtlCol="0" anchor="ctr"/>
+          <a:lstStyle/>
+          <a:p>
+            <a:pPr algn="ctr"/>
+            <a:endParaRPr/>
+          </a:p>
+        </p:txBody>
+      </p:sp>
+      <p:sp>
+        <p:nvSpPr>
+          <p:cNvPr id="17" name="build03 TextBox 16"/>
           <p:cNvSpPr txBox="1"/>
           <p:nvPr/>
         </p:nvSpPr>
         <p:spPr>
           <a:xfrm>
-            <a:off x="6598767" y="4251960"/>
-            <a:ext cx="4724247" cy="457200"/>
+            <a:off x="8402116" y="1783080"/>
+            <a:ext cx="2966618" cy="411480"/>
           </a:xfrm>
           <a:prstGeom prst="rect">
             <a:avLst/>
@@ -7287,35 +7341,169 @@
               </a:lnSpc>
             </a:pPr>
             <a:r>
-              <a:rPr sz="1600" b="1" i="0">
+              <a:rPr sz="2000" b="1" i="0">
                 <a:solidFill>
-                  <a:srgbClr val="4338CA"/>
+                  <a:srgbClr val="0F172A"/>
                 </a:solidFill>
                 <a:latin typeface="Arial"/>
               </a:rPr>
-              <a:t>Good for: </a:t>
+              <a:t>Each tool</a:t>
             </a:r>
+          </a:p>
+        </p:txBody>
+      </p:sp>
+      <p:sp>
+        <p:nvSpPr>
+          <p:cNvPr id="18" name="build03 Rounded Rectangle 17"/>
+          <p:cNvSpPr/>
+          <p:nvPr/>
+        </p:nvSpPr>
+        <p:spPr>
+          <a:xfrm>
+            <a:off x="8402116" y="2331720"/>
+            <a:ext cx="2966618" cy="502920"/>
+          </a:xfrm>
+          <a:prstGeom prst="roundRect">
+            <a:avLst>
+              <a:gd name="adj" fmla="val 6000"/>
+            </a:avLst>
+          </a:prstGeom>
+          <a:solidFill>
+            <a:srgbClr val="0F172A"/>
+          </a:solidFill>
+          <a:ln>
+            <a:noFill/>
+          </a:ln>
+          <a:effectLst/>
+        </p:spPr>
+        <p:style>
+          <a:lnRef idx="1">
+            <a:schemeClr val="accent1"/>
+          </a:lnRef>
+          <a:fillRef idx="3">
+            <a:schemeClr val="accent1"/>
+          </a:fillRef>
+          <a:effectRef idx="2">
+            <a:schemeClr val="accent1"/>
+          </a:effectRef>
+          <a:fontRef idx="minor">
+            <a:schemeClr val="lt1"/>
+          </a:fontRef>
+        </p:style>
+        <p:txBody>
+          <a:bodyPr rtlCol="0" anchor="ctr"/>
+          <a:lstStyle/>
+          <a:p>
+            <a:pPr algn="ctr"/>
+            <a:endParaRPr/>
+          </a:p>
+        </p:txBody>
+      </p:sp>
+      <p:sp>
+        <p:nvSpPr>
+          <p:cNvPr id="19" name="build03 TextBox 18"/>
+          <p:cNvSpPr txBox="1"/>
+          <p:nvPr/>
+        </p:nvSpPr>
+        <p:spPr>
+          <a:xfrm>
+            <a:off x="8539276" y="2331720"/>
+            <a:ext cx="2692298" cy="502920"/>
+          </a:xfrm>
+          <a:prstGeom prst="rect">
+            <a:avLst/>
+          </a:prstGeom>
+          <a:noFill/>
+        </p:spPr>
+        <p:txBody>
+          <a:bodyPr wrap="square" lIns="0" tIns="0" rIns="0" bIns="0" anchor="ctr">
+            <a:spAutoFit/>
+          </a:bodyPr>
+          <a:lstStyle/>
+          <a:p>
+            <a:pPr algn="l">
+              <a:lnSpc>
+                <a:spcPct val="110000"/>
+              </a:lnSpc>
+            </a:pPr>
             <a:r>
-              <a:rPr sz="1600" b="0" i="0">
+              <a:rPr sz="1400" b="1" i="0">
+                <a:solidFill>
+                  <a:srgbClr val="FFFFFF"/>
+                </a:solidFill>
+                <a:latin typeface="Courier New"/>
+              </a:rPr>
+              <a:t>devexai install &lt;tool&gt;</a:t>
+            </a:r>
+          </a:p>
+        </p:txBody>
+      </p:sp>
+      <p:sp>
+        <p:nvSpPr>
+          <p:cNvPr id="20" name="build03 TextBox 19"/>
+          <p:cNvSpPr txBox="1"/>
+          <p:nvPr/>
+        </p:nvSpPr>
+        <p:spPr>
+          <a:xfrm>
+            <a:off x="8402116" y="2971800"/>
+            <a:ext cx="2966618" cy="1463040"/>
+          </a:xfrm>
+          <a:prstGeom prst="rect">
+            <a:avLst/>
+          </a:prstGeom>
+          <a:noFill/>
+        </p:spPr>
+        <p:txBody>
+          <a:bodyPr wrap="square" lIns="0" tIns="0" rIns="0" bIns="0" anchor="t">
+            <a:spAutoFit/>
+          </a:bodyPr>
+          <a:lstStyle/>
+          <a:p>
+            <a:pPr algn="l">
+              <a:lnSpc>
+                <a:spcPct val="110000"/>
+              </a:lnSpc>
+            </a:pPr>
+            <a:r>
+              <a:rPr sz="1400" b="0" i="0">
                 <a:solidFill>
                   <a:srgbClr val="1E293B"/>
                 </a:solidFill>
                 <a:latin typeface="Arial"/>
               </a:rPr>
-              <a:t>Personal productivity tools</a:t>
+              <a:t>Copied from the blog post. Goes into this project's .claude/, .gemini/ and .codex/ by default; </a:t>
             </a:r>
-          </a:p>
-        </p:txBody>
-      </p:sp>
-      <p:sp>
-        <p:nvSpPr>
-          <p:cNvPr id="18" name="build03 Rounded Rectangle 17"/>
+            <a:r>
+              <a:rPr sz="1400" b="1" i="0">
+                <a:solidFill>
+                  <a:srgbClr val="0F172A"/>
+                </a:solidFill>
+                <a:latin typeface="Courier New"/>
+              </a:rPr>
+              <a:t>--global</a:t>
+            </a:r>
+            <a:r>
+              <a:rPr sz="1400" b="0" i="0">
+                <a:solidFill>
+                  <a:srgbClr val="1E293B"/>
+                </a:solidFill>
+                <a:latin typeface="Arial"/>
+              </a:rPr>
+              <a:t> for your whole machine.</a:t>
+            </a:r>
+          </a:p>
+        </p:txBody>
+      </p:sp>
+      <p:sp>
+        <p:nvSpPr>
+          <p:cNvPr id="21" name="build04 Rounded Rectangle 20"/>
           <p:cNvSpPr/>
           <p:nvPr/>
         </p:nvSpPr>
         <p:spPr>
           <a:xfrm>
-            <a:off x="548640" y="5120640"/>
+            <a:off x="548640" y="4754880"/>
             <a:ext cx="3515258" cy="594360"/>
           </a:xfrm>
           <a:prstGeom prst="roundRect">
@@ -7356,13 +7544,13 @@
       </p:sp>
       <p:sp>
         <p:nvSpPr>
-          <p:cNvPr id="19" name="build03 TextBox 18"/>
+          <p:cNvPr id="22" name="build04 TextBox 21"/>
           <p:cNvSpPr txBox="1"/>
           <p:nvPr/>
         </p:nvSpPr>
         <p:spPr>
           <a:xfrm>
-            <a:off x="621792" y="5120640"/>
+            <a:off x="621792" y="4754880"/>
             <a:ext cx="3368954" cy="594360"/>
           </a:xfrm>
           <a:prstGeom prst="rect">
@@ -7395,13 +7583,13 @@
       </p:sp>
       <p:sp>
         <p:nvSpPr>
-          <p:cNvPr id="20" name="build03 Rounded Rectangle 19"/>
+          <p:cNvPr id="23" name="build04 Rounded Rectangle 22"/>
           <p:cNvSpPr/>
           <p:nvPr/>
         </p:nvSpPr>
         <p:spPr>
           <a:xfrm>
-            <a:off x="4338218" y="5120640"/>
+            <a:off x="4338218" y="4754880"/>
             <a:ext cx="3515258" cy="594360"/>
           </a:xfrm>
           <a:prstGeom prst="roundRect">
@@ -7442,13 +7630,13 @@
       </p:sp>
       <p:sp>
         <p:nvSpPr>
-          <p:cNvPr id="21" name="build03 TextBox 20"/>
+          <p:cNvPr id="24" name="build04 TextBox 23"/>
           <p:cNvSpPr txBox="1"/>
           <p:nvPr/>
         </p:nvSpPr>
         <p:spPr>
           <a:xfrm>
-            <a:off x="4411370" y="5120640"/>
+            <a:off x="4411370" y="4754880"/>
             <a:ext cx="3368954" cy="594360"/>
           </a:xfrm>
           <a:prstGeom prst="rect">
@@ -7481,13 +7669,13 @@
       </p:sp>
       <p:sp>
         <p:nvSpPr>
-          <p:cNvPr id="22" name="build03 Rounded Rectangle 21"/>
+          <p:cNvPr id="25" name="build04 Rounded Rectangle 24"/>
           <p:cNvSpPr/>
           <p:nvPr/>
         </p:nvSpPr>
         <p:spPr>
           <a:xfrm>
-            <a:off x="8127796" y="5120640"/>
+            <a:off x="8127796" y="4754880"/>
             <a:ext cx="3515258" cy="594360"/>
           </a:xfrm>
           <a:prstGeom prst="roundRect">
@@ -7528,13 +7716,13 @@
       </p:sp>
       <p:sp>
         <p:nvSpPr>
-          <p:cNvPr id="23" name="build03 TextBox 22"/>
+          <p:cNvPr id="26" name="build04 TextBox 25"/>
           <p:cNvSpPr txBox="1"/>
           <p:nvPr/>
         </p:nvSpPr>
         <p:spPr>
           <a:xfrm>
-            <a:off x="8200948" y="5120640"/>
+            <a:off x="8200948" y="4754880"/>
             <a:ext cx="3368954" cy="594360"/>
           </a:xfrm>
           <a:prstGeom prst="rect">
@@ -7567,14 +7755,14 @@
       </p:sp>
       <p:sp>
         <p:nvSpPr>
-          <p:cNvPr id="24" name="build03 TextBox 23"/>
+          <p:cNvPr id="27" name="build04 TextBox 26"/>
           <p:cNvSpPr txBox="1"/>
           <p:nvPr/>
         </p:nvSpPr>
         <p:spPr>
           <a:xfrm>
-            <a:off x="548640" y="5852160"/>
-            <a:ext cx="11094415" cy="411480"/>
+            <a:off x="548640" y="5577840"/>
+            <a:ext cx="11094415" cy="457200"/>
           </a:xfrm>
           <a:prstGeom prst="rect">
             <a:avLst/>
@@ -7592,6 +7780,24 @@
                 <a:spcPct val="110000"/>
               </a:lnSpc>
             </a:pPr>
+            <a:r>
+              <a:rPr sz="1400" b="1" i="0">
+                <a:solidFill>
+                  <a:srgbClr val="4338CA"/>
+                </a:solidFill>
+                <a:latin typeface="Arial"/>
+              </a:rPr>
+              <a:t>Also: </a:t>
+            </a:r>
+            <a:r>
+              <a:rPr sz="1400" b="1" i="0">
+                <a:solidFill>
+                  <a:srgbClr val="0F172A"/>
+                </a:solidFill>
+                <a:latin typeface="Courier New"/>
+              </a:rPr>
+              <a:t>devexai list</a:t>
+            </a:r>
             <a:r>
               <a:rPr sz="1400" b="0" i="0">
                 <a:solidFill>
@@ -7599,7 +7805,43 @@
                 </a:solidFill>
                 <a:latin typeface="Arial"/>
               </a:rPr>
-              <a:t>devex.py is one Python file from /blog/devex.py. It never edits settings files, and never overwrites other files without --force.</a:t>
+              <a:t>, </a:t>
+            </a:r>
+            <a:r>
+              <a:rPr sz="1400" b="1" i="0">
+                <a:solidFill>
+                  <a:srgbClr val="0F172A"/>
+                </a:solidFill>
+                <a:latin typeface="Courier New"/>
+              </a:rPr>
+              <a:t>devexai uninstall &lt;tool&gt;</a:t>
+            </a:r>
+            <a:r>
+              <a:rPr sz="1400" b="0" i="0">
+                <a:solidFill>
+                  <a:srgbClr val="475569"/>
+                </a:solidFill>
+                <a:latin typeface="Arial"/>
+              </a:rPr>
+              <a:t>, </a:t>
+            </a:r>
+            <a:r>
+              <a:rPr sz="1400" b="1" i="0">
+                <a:solidFill>
+                  <a:srgbClr val="0F172A"/>
+                </a:solidFill>
+                <a:latin typeface="Courier New"/>
+              </a:rPr>
+              <a:t>devexai update</a:t>
+            </a:r>
+            <a:r>
+              <a:rPr sz="1400" b="0" i="0">
+                <a:solidFill>
+                  <a:srgbClr val="475569"/>
+                </a:solidFill>
+                <a:latin typeface="Arial"/>
+              </a:rPr>
+              <a:t>. Settings files are never edited; other files are never overwritten without --force.</a:t>
             </a:r>
           </a:p>
         </p:txBody>
@@ -7810,15 +8052,24 @@
                                   </p:childTnLst>
                                 </p:cTn>
                               </p:par>
+                            </p:childTnLst>
+                          </p:cTn>
+                        </p:par>
+                        <p:par>
+                          <p:cTn id="20" fill="hold">
+                            <p:stCondLst>
+                              <p:cond delay="400"/>
+                            </p:stCondLst>
+                            <p:childTnLst>
                               <p:par>
-                                <p:cTn id="20" presetID="10" presetClass="entr" presetSubtype="0" fill="hold" grpId="0" nodeType="withEffect">
+                                <p:cTn id="21" presetID="10" presetClass="entr" presetSubtype="0" fill="hold" grpId="0" nodeType="afterEffect">
                                   <p:stCondLst>
                                     <p:cond delay="0"/>
                                   </p:stCondLst>
                                   <p:childTnLst>
                                     <p:set>
                                       <p:cBhvr>
-                                        <p:cTn id="21" dur="1" fill="hold">
+                                        <p:cTn id="22" dur="1" fill="hold">
                                           <p:stCondLst>
                                             <p:cond delay="0"/>
                                           </p:stCondLst>
@@ -7836,7 +8087,7 @@
                                     </p:set>
                                     <p:animEffect transition="in" filter="fade">
                                       <p:cBhvr>
-                                        <p:cTn id="22" dur="400"/>
+                                        <p:cTn id="23" dur="400"/>
                                         <p:tgtEl>
                                           <p:spTgt spid="11"/>
                                         </p:tgtEl>
@@ -7845,17 +8096,8 @@
                                   </p:childTnLst>
                                 </p:cTn>
                               </p:par>
-                            </p:childTnLst>
-                          </p:cTn>
-                        </p:par>
-                        <p:par>
-                          <p:cTn id="23" fill="hold">
-                            <p:stCondLst>
-                              <p:cond delay="400"/>
-                            </p:stCondLst>
-                            <p:childTnLst>
                               <p:par>
-                                <p:cTn id="24" presetID="10" presetClass="entr" presetSubtype="0" fill="hold" grpId="0" nodeType="afterEffect">
+                                <p:cTn id="24" presetID="10" presetClass="entr" presetSubtype="0" fill="hold" grpId="0" nodeType="withEffect">
                                   <p:stCondLst>
                                     <p:cond delay="0"/>
                                   </p:stCondLst>
@@ -7994,15 +8236,24 @@
                                   </p:childTnLst>
                                 </p:cTn>
                               </p:par>
+                            </p:childTnLst>
+                          </p:cTn>
+                        </p:par>
+                        <p:par>
+                          <p:cTn id="36" fill="hold">
+                            <p:stCondLst>
+                              <p:cond delay="800"/>
+                            </p:stCondLst>
+                            <p:childTnLst>
                               <p:par>
-                                <p:cTn id="36" presetID="10" presetClass="entr" presetSubtype="0" fill="hold" grpId="0" nodeType="withEffect">
+                                <p:cTn id="37" presetID="10" presetClass="entr" presetSubtype="0" fill="hold" grpId="0" nodeType="afterEffect">
                                   <p:stCondLst>
                                     <p:cond delay="0"/>
                                   </p:stCondLst>
                                   <p:childTnLst>
                                     <p:set>
                                       <p:cBhvr>
-                                        <p:cTn id="37" dur="1" fill="hold">
+                                        <p:cTn id="38" dur="1" fill="hold">
                                           <p:stCondLst>
                                             <p:cond delay="0"/>
                                           </p:stCondLst>
@@ -8020,7 +8271,7 @@
                                     </p:set>
                                     <p:animEffect transition="in" filter="fade">
                                       <p:cBhvr>
-                                        <p:cTn id="38" dur="400"/>
+                                        <p:cTn id="39" dur="400"/>
                                         <p:tgtEl>
                                           <p:spTgt spid="16"/>
                                         </p:tgtEl>
@@ -8030,14 +8281,14 @@
                                 </p:cTn>
                               </p:par>
                               <p:par>
-                                <p:cTn id="39" presetID="10" presetClass="entr" presetSubtype="0" fill="hold" grpId="0" nodeType="withEffect">
+                                <p:cTn id="40" presetID="10" presetClass="entr" presetSubtype="0" fill="hold" grpId="0" nodeType="withEffect">
                                   <p:stCondLst>
                                     <p:cond delay="0"/>
                                   </p:stCondLst>
                                   <p:childTnLst>
                                     <p:set>
                                       <p:cBhvr>
-                                        <p:cTn id="40" dur="1" fill="hold">
+                                        <p:cTn id="41" dur="1" fill="hold">
                                           <p:stCondLst>
                                             <p:cond delay="0"/>
                                           </p:stCondLst>
@@ -8055,7 +8306,7 @@
                                     </p:set>
                                     <p:animEffect transition="in" filter="fade">
                                       <p:cBhvr>
-                                        <p:cTn id="41" dur="400"/>
+                                        <p:cTn id="42" dur="400"/>
                                         <p:tgtEl>
                                           <p:spTgt spid="17"/>
                                         </p:tgtEl>
@@ -8064,17 +8315,8 @@
                                   </p:childTnLst>
                                 </p:cTn>
                               </p:par>
-                            </p:childTnLst>
-                          </p:cTn>
-                        </p:par>
-                        <p:par>
-                          <p:cTn id="42" fill="hold">
-                            <p:stCondLst>
-                              <p:cond delay="800"/>
-                            </p:stCondLst>
-                            <p:childTnLst>
                               <p:par>
-                                <p:cTn id="43" presetID="10" presetClass="entr" presetSubtype="0" fill="hold" grpId="0" nodeType="afterEffect">
+                                <p:cTn id="43" presetID="10" presetClass="entr" presetSubtype="0" fill="hold" grpId="0" nodeType="withEffect">
                                   <p:stCondLst>
                                     <p:cond delay="0"/>
                                   </p:stCondLst>
@@ -8178,15 +8420,24 @@
                                   </p:childTnLst>
                                 </p:cTn>
                               </p:par>
+                            </p:childTnLst>
+                          </p:cTn>
+                        </p:par>
+                        <p:par>
+                          <p:cTn id="52" fill="hold">
+                            <p:stCondLst>
+                              <p:cond delay="1200"/>
+                            </p:stCondLst>
+                            <p:childTnLst>
                               <p:par>
-                                <p:cTn id="52" presetID="10" presetClass="entr" presetSubtype="0" fill="hold" grpId="0" nodeType="withEffect">
+                                <p:cTn id="53" presetID="10" presetClass="entr" presetSubtype="0" fill="hold" grpId="0" nodeType="afterEffect">
                                   <p:stCondLst>
                                     <p:cond delay="0"/>
                                   </p:stCondLst>
                                   <p:childTnLst>
                                     <p:set>
                                       <p:cBhvr>
-                                        <p:cTn id="53" dur="1" fill="hold">
+                                        <p:cTn id="54" dur="1" fill="hold">
                                           <p:stCondLst>
                                             <p:cond delay="0"/>
                                           </p:stCondLst>
@@ -8204,7 +8455,7 @@
                                     </p:set>
                                     <p:animEffect transition="in" filter="fade">
                                       <p:cBhvr>
-                                        <p:cTn id="54" dur="400"/>
+                                        <p:cTn id="55" dur="400"/>
                                         <p:tgtEl>
                                           <p:spTgt spid="21"/>
                                         </p:tgtEl>
@@ -8214,14 +8465,14 @@
                                 </p:cTn>
                               </p:par>
                               <p:par>
-                                <p:cTn id="55" presetID="10" presetClass="entr" presetSubtype="0" fill="hold" grpId="0" nodeType="withEffect">
+                                <p:cTn id="56" presetID="10" presetClass="entr" presetSubtype="0" fill="hold" grpId="0" nodeType="withEffect">
                                   <p:stCondLst>
                                     <p:cond delay="0"/>
                                   </p:stCondLst>
                                   <p:childTnLst>
                                     <p:set>
                                       <p:cBhvr>
-                                        <p:cTn id="56" dur="1" fill="hold">
+                                        <p:cTn id="57" dur="1" fill="hold">
                                           <p:stCondLst>
                                             <p:cond delay="0"/>
                                           </p:stCondLst>
@@ -8239,7 +8490,7 @@
                                     </p:set>
                                     <p:animEffect transition="in" filter="fade">
                                       <p:cBhvr>
-                                        <p:cTn id="57" dur="400"/>
+                                        <p:cTn id="58" dur="400"/>
                                         <p:tgtEl>
                                           <p:spTgt spid="22"/>
                                         </p:tgtEl>
@@ -8249,14 +8500,14 @@
                                 </p:cTn>
                               </p:par>
                               <p:par>
-                                <p:cTn id="58" presetID="10" presetClass="entr" presetSubtype="0" fill="hold" grpId="0" nodeType="withEffect">
+                                <p:cTn id="59" presetID="10" presetClass="entr" presetSubtype="0" fill="hold" grpId="0" nodeType="withEffect">
                                   <p:stCondLst>
                                     <p:cond delay="0"/>
                                   </p:stCondLst>
                                   <p:childTnLst>
                                     <p:set>
                                       <p:cBhvr>
-                                        <p:cTn id="59" dur="1" fill="hold">
+                                        <p:cTn id="60" dur="1" fill="hold">
                                           <p:stCondLst>
                                             <p:cond delay="0"/>
                                           </p:stCondLst>
@@ -8274,7 +8525,7 @@
                                     </p:set>
                                     <p:animEffect transition="in" filter="fade">
                                       <p:cBhvr>
-                                        <p:cTn id="60" dur="400"/>
+                                        <p:cTn id="61" dur="400"/>
                                         <p:tgtEl>
                                           <p:spTgt spid="23"/>
                                         </p:tgtEl>
@@ -8284,14 +8535,14 @@
                                 </p:cTn>
                               </p:par>
                               <p:par>
-                                <p:cTn id="61" presetID="10" presetClass="entr" presetSubtype="0" fill="hold" grpId="0" nodeType="withEffect">
+                                <p:cTn id="62" presetID="10" presetClass="entr" presetSubtype="0" fill="hold" grpId="0" nodeType="withEffect">
                                   <p:stCondLst>
                                     <p:cond delay="0"/>
                                   </p:stCondLst>
                                   <p:childTnLst>
                                     <p:set>
                                       <p:cBhvr>
-                                        <p:cTn id="62" dur="1" fill="hold">
+                                        <p:cTn id="63" dur="1" fill="hold">
                                           <p:stCondLst>
                                             <p:cond delay="0"/>
                                           </p:stCondLst>
@@ -8309,9 +8560,114 @@
                                     </p:set>
                                     <p:animEffect transition="in" filter="fade">
                                       <p:cBhvr>
-                                        <p:cTn id="63" dur="400"/>
+                                        <p:cTn id="64" dur="400"/>
                                         <p:tgtEl>
                                           <p:spTgt spid="24"/>
+                                        </p:tgtEl>
+                                      </p:cBhvr>
+                                    </p:animEffect>
+                                  </p:childTnLst>
+                                </p:cTn>
+                              </p:par>
+                              <p:par>
+                                <p:cTn id="65" presetID="10" presetClass="entr" presetSubtype="0" fill="hold" grpId="0" nodeType="withEffect">
+                                  <p:stCondLst>
+                                    <p:cond delay="0"/>
+                                  </p:stCondLst>
+                                  <p:childTnLst>
+                                    <p:set>
+                                      <p:cBhvr>
+                                        <p:cTn id="66" dur="1" fill="hold">
+                                          <p:stCondLst>
+                                            <p:cond delay="0"/>
+                                          </p:stCondLst>
+                                        </p:cTn>
+                                        <p:tgtEl>
+                                          <p:spTgt spid="25"/>
+                                        </p:tgtEl>
+                                        <p:attrNameLst>
+                                          <p:attrName>style.visibility</p:attrName>
+                                        </p:attrNameLst>
+                                      </p:cBhvr>
+                                      <p:to>
+                                        <p:strVal val="visible"/>
+                                      </p:to>
+                                    </p:set>
+                                    <p:animEffect transition="in" filter="fade">
+                                      <p:cBhvr>
+                                        <p:cTn id="67" dur="400"/>
+                                        <p:tgtEl>
+                                          <p:spTgt spid="25"/>
+                                        </p:tgtEl>
+                                      </p:cBhvr>
+                                    </p:animEffect>
+                                  </p:childTnLst>
+                                </p:cTn>
+                              </p:par>
+                              <p:par>
+                                <p:cTn id="68" presetID="10" presetClass="entr" presetSubtype="0" fill="hold" grpId="0" nodeType="withEffect">
+                                  <p:stCondLst>
+                                    <p:cond delay="0"/>
+                                  </p:stCondLst>
+                                  <p:childTnLst>
+                                    <p:set>
+                                      <p:cBhvr>
+                                        <p:cTn id="69" dur="1" fill="hold">
+                                          <p:stCondLst>
+                                            <p:cond delay="0"/>
+                                          </p:stCondLst>
+                                        </p:cTn>
+                                        <p:tgtEl>
+                                          <p:spTgt spid="26"/>
+                                        </p:tgtEl>
+                                        <p:attrNameLst>
+                                          <p:attrName>style.visibility</p:attrName>
+                                        </p:attrNameLst>
+                                      </p:cBhvr>
+                                      <p:to>
+                                        <p:strVal val="visible"/>
+                                      </p:to>
+                                    </p:set>
+                                    <p:animEffect transition="in" filter="fade">
+                                      <p:cBhvr>
+                                        <p:cTn id="70" dur="400"/>
+                                        <p:tgtEl>
+                                          <p:spTgt spid="26"/>
+                                        </p:tgtEl>
+                                      </p:cBhvr>
+                                    </p:animEffect>
+                                  </p:childTnLst>
+                                </p:cTn>
+                              </p:par>
+                              <p:par>
+                                <p:cTn id="71" presetID="10" presetClass="entr" presetSubtype="0" fill="hold" grpId="0" nodeType="withEffect">
+                                  <p:stCondLst>
+                                    <p:cond delay="0"/>
+                                  </p:stCondLst>
+                                  <p:childTnLst>
+                                    <p:set>
+                                      <p:cBhvr>
+                                        <p:cTn id="72" dur="1" fill="hold">
+                                          <p:stCondLst>
+                                            <p:cond delay="0"/>
+                                          </p:stCondLst>
+                                        </p:cTn>
+                                        <p:tgtEl>
+                                          <p:spTgt spid="27"/>
+                                        </p:tgtEl>
+                                        <p:attrNameLst>
+                                          <p:attrName>style.visibility</p:attrName>
+                                        </p:attrNameLst>
+                                      </p:cBhvr>
+                                      <p:to>
+                                        <p:strVal val="visible"/>
+                                      </p:to>
+                                    </p:set>
+                                    <p:animEffect transition="in" filter="fade">
+                                      <p:cBhvr>
+                                        <p:cTn id="73" dur="400"/>
+                                        <p:tgtEl>
+                                          <p:spTgt spid="27"/>
                                         </p:tgtEl>
                                       </p:cBhvr>
                                     </p:animEffect>
@@ -8351,20 +8707,23 @@
       <p:bldP spid="8" grpId="0" animBg="1"/>
       <p:bldP spid="9" grpId="0"/>
       <p:bldP spid="10" grpId="0"/>
-      <p:bldP spid="11" grpId="0"/>
-      <p:bldP spid="12" grpId="0" animBg="1"/>
-      <p:bldP spid="13" grpId="0"/>
-      <p:bldP spid="14" grpId="0" animBg="1"/>
+      <p:bldP spid="11" grpId="0" animBg="1"/>
+      <p:bldP spid="12" grpId="0"/>
+      <p:bldP spid="13" grpId="0" animBg="1"/>
+      <p:bldP spid="14" grpId="0"/>
       <p:bldP spid="15" grpId="0"/>
-      <p:bldP spid="16" grpId="0"/>
+      <p:bldP spid="16" grpId="0" animBg="1"/>
       <p:bldP spid="17" grpId="0"/>
       <p:bldP spid="18" grpId="0" animBg="1"/>
       <p:bldP spid="19" grpId="0"/>
-      <p:bldP spid="20" grpId="0" animBg="1"/>
-      <p:bldP spid="21" grpId="0"/>
-      <p:bldP spid="22" grpId="0" animBg="1"/>
-      <p:bldP spid="23" grpId="0"/>
+      <p:bldP spid="20" grpId="0"/>
+      <p:bldP spid="21" grpId="0" animBg="1"/>
+      <p:bldP spid="22" grpId="0"/>
+      <p:bldP spid="23" grpId="0" animBg="1"/>
       <p:bldP spid="24" grpId="0"/>
+      <p:bldP spid="25" grpId="0" animBg="1"/>
+      <p:bldP spid="26" grpId="0"/>
+      <p:bldP spid="27" grpId="0"/>
     </p:bldLst>
   </p:timing>
 </p:sld>

</xml_diff>

<commit_message>
Deck in plain language, matches the updated README
Co-Authored-By: Claude Opus 5.5 <noreply@anthropic.com>
</commit_message>
<xml_diff>
--- a/DevExAI.pptx
+++ b/DevExAI.pptx
@@ -169,7 +169,7 @@
     </p:spTree>
     <p:extLst>
       <p:ext uri="{BB962C8B-B14F-4D97-AF65-F5344CB8AC3E}">
-        <p14:creationId xmlns:p14="http://schemas.microsoft.com/office/powerpoint/2010/main" val="2267641224"/>
+        <p14:creationId xmlns:p14="http://schemas.microsoft.com/office/powerpoint/2010/main" val="3928520941"/>
       </p:ext>
     </p:extLst>
   </p:cSld>
@@ -3700,7 +3700,7 @@
                 </a:solidFill>
                 <a:latin typeface="Arial"/>
               </a:rPr>
-              <a:t>PROPOSAL · DRAFT FOR REVIEW</a:t>
+              <a:t>PROPOSAL, DRAFT FOR REVIEW</a:t>
             </a:r>
           </a:p>
         </p:txBody>
@@ -3739,7 +3739,7 @@
                 </a:solidFill>
                 <a:latin typeface="Arial"/>
               </a:rPr>
-              <a:t>DevExAI — the company AI toolsmith</a:t>
+              <a:t>DevExAI: the company AI toolsmith</a:t>
             </a:r>
           </a:p>
         </p:txBody>
@@ -3864,7 +3864,7 @@
                 </a:solidFill>
                 <a:latin typeface="Arial"/>
               </a:rPr>
-              <a:t>Claude · Gemini · ChatGPT</a:t>
+              <a:t>Claude, Gemini, ChatGPT</a:t>
             </a:r>
           </a:p>
         </p:txBody>
@@ -4506,7 +4506,7 @@
                 </a:solidFill>
                 <a:latin typeface="Arial"/>
               </a:rPr>
-              <a:t>09 · WHAT GETS BUILT</a:t>
+              <a:t>9. WHAT GETS BUILT</a:t>
             </a:r>
           </a:p>
         </p:txBody>
@@ -4623,7 +4623,7 @@
                 </a:solidFill>
                 <a:latin typeface="Arial"/>
               </a:rPr>
-              <a:t>DevExAI · proposal draft</a:t>
+              <a:t>DevExAI, proposal draft</a:t>
             </a:r>
           </a:p>
         </p:txBody>
@@ -4793,7 +4793,7 @@
                 </a:solidFill>
                 <a:latin typeface="Arial"/>
               </a:rPr>
-              <a:t>Reusable “how to do X” guides the assistant follows.</a:t>
+              <a:t>Reusable "how to do X" guides the assistant follows.</a:t>
             </a:r>
           </a:p>
         </p:txBody>
@@ -4924,7 +4924,7 @@
                 </a:solidFill>
                 <a:latin typeface="Arial"/>
               </a:rPr>
-              <a:t>MCP servers</a:t>
+              <a:t>Connectors</a:t>
             </a:r>
           </a:p>
         </p:txBody>
@@ -4963,7 +4963,7 @@
                 </a:solidFill>
                 <a:latin typeface="Arial"/>
               </a:rPr>
-              <a:t>Small services that give assistants new abilities, e.g. read the issue tracker.</a:t>
+              <a:t>Small add-ons that give assistants new abilities, like reading the issue tracker.</a:t>
             </a:r>
           </a:p>
         </p:txBody>
@@ -5094,7 +5094,7 @@
                 </a:solidFill>
                 <a:latin typeface="Arial"/>
               </a:rPr>
-              <a:t>Tools &amp; scripts</a:t>
+              <a:t>Tools and scripts</a:t>
             </a:r>
           </a:p>
         </p:txBody>
@@ -5428,7 +5428,7 @@
                 </a:solidFill>
                 <a:latin typeface="Arial"/>
               </a:rPr>
-              <a:t>Claude · Claude Code</a:t>
+              <a:t>Claude: Claude Code</a:t>
             </a:r>
           </a:p>
         </p:txBody>
@@ -5514,7 +5514,7 @@
                 </a:solidFill>
                 <a:latin typeface="Arial"/>
               </a:rPr>
-              <a:t>Gemini · Gemini CLI</a:t>
+              <a:t>Gemini: Gemini CLI</a:t>
             </a:r>
           </a:p>
         </p:txBody>
@@ -5600,7 +5600,7 @@
                 </a:solidFill>
                 <a:latin typeface="Arial"/>
               </a:rPr>
-              <a:t>ChatGPT · Codex</a:t>
+              <a:t>ChatGPT: Codex</a:t>
             </a:r>
           </a:p>
         </p:txBody>
@@ -5639,7 +5639,7 @@
                 </a:solidFill>
                 <a:latin typeface="Arial"/>
               </a:rPr>
-              <a:t>The builder writes Claude Code files today. Later: one shared core with a thin adapter per assistant, so an idea is never rebuilt three times.</a:t>
+              <a:t>The builder writes Claude Code files today. Later: one shared tool with a small layer for each assistant, so an idea is never built three times.</a:t>
             </a:r>
           </a:p>
         </p:txBody>
@@ -6667,7 +6667,7 @@
                 </a:solidFill>
                 <a:latin typeface="Arial"/>
               </a:rPr>
-              <a:t>10 · INSTALLING</a:t>
+              <a:t>10. INSTALLING</a:t>
             </a:r>
           </a:p>
         </p:txBody>
@@ -6784,7 +6784,7 @@
                 </a:solidFill>
                 <a:latin typeface="Arial"/>
               </a:rPr>
-              <a:t>DevExAI · proposal draft</a:t>
+              <a:t>DevExAI, proposal draft</a:t>
             </a:r>
           </a:p>
         </p:txBody>
@@ -7013,7 +7013,7 @@
                 </a:solidFill>
                 <a:latin typeface="Arial"/>
               </a:rPr>
-              <a:t> starts the bot and dashboard in the background and opens it; run again, it only opens the dashboard.</a:t>
+              <a:t> starts the bot and opens the dashboard. Running it again just opens the dashboard.</a:t>
             </a:r>
           </a:p>
         </p:txBody>
@@ -7224,7 +7224,7 @@
                 </a:solidFill>
                 <a:latin typeface="Arial"/>
               </a:rPr>
-              <a:t>From the dashboard's /get page. Asks for the server, trusts the company CA, puts </a:t>
+              <a:t>From the dashboard's Get DevExAI page. Connects to the server, trusts the company certificate and adds the </a:t>
             </a:r>
             <a:r>
               <a:rPr sz="1400" b="1" i="0">
@@ -7242,7 +7242,7 @@
                 </a:solidFill>
                 <a:latin typeface="Arial"/>
               </a:rPr>
-              <a:t> on PATH. No admin code inside.</a:t>
+              <a:t> command.</a:t>
             </a:r>
           </a:p>
           <a:p>
@@ -7261,7 +7261,7 @@
                 </a:solidFill>
                 <a:latin typeface="Arial"/>
               </a:rPr>
-              <a:t>Linux: one curl | sh line from the same page.</a:t>
+              <a:t>Linux: one command from the same page.</a:t>
             </a:r>
           </a:p>
         </p:txBody>
@@ -7472,7 +7472,7 @@
                 </a:solidFill>
                 <a:latin typeface="Arial"/>
               </a:rPr>
-              <a:t>Copied from the blog post. Goes into this project's .claude/, .gemini/ and .codex/ by default; </a:t>
+              <a:t>Copied from the blog post. Adds the tool to this project; add </a:t>
             </a:r>
             <a:r>
               <a:rPr sz="1400" b="1" i="0">
@@ -7490,7 +7490,7 @@
                 </a:solidFill>
                 <a:latin typeface="Arial"/>
               </a:rPr>
-              <a:t> for your whole machine.</a:t>
+              <a:t> for every project.</a:t>
             </a:r>
           </a:p>
         </p:txBody>
@@ -7841,7 +7841,7 @@
                 </a:solidFill>
                 <a:latin typeface="Arial"/>
               </a:rPr>
-              <a:t>. Settings files are never edited; other files are never overwritten without --force.</a:t>
+              <a:t>. It never changes your settings files and never replaces your own files unless you ask.</a:t>
             </a:r>
           </a:p>
         </p:txBody>
@@ -8788,7 +8788,7 @@
                 </a:solidFill>
                 <a:latin typeface="Arial"/>
               </a:rPr>
-              <a:t>11 · WHICH AI DOES WHAT</a:t>
+              <a:t>11. WHICH AI DOES WHAT</a:t>
             </a:r>
           </a:p>
         </p:txBody>
@@ -8827,7 +8827,7 @@
                 </a:solidFill>
                 <a:latin typeface="Arial"/>
               </a:rPr>
-              <a:t>Opus thinks and reviews; cheaper models will type</a:t>
+              <a:t>Opus thinks and checks; cheaper models will write</a:t>
             </a:r>
           </a:p>
         </p:txBody>
@@ -8905,7 +8905,7 @@
                 </a:solidFill>
                 <a:latin typeface="Arial"/>
               </a:rPr>
-              <a:t>DevExAI · proposal draft</a:t>
+              <a:t>DevExAI, proposal draft</a:t>
             </a:r>
           </a:p>
         </p:txBody>
@@ -9059,7 +9059,7 @@
                           </a:solidFill>
                           <a:latin typeface="Arial"/>
                         </a:rPr>
-                        <a:t>Claude Opus; malware and secret scanners to add</a:t>
+                        <a:t>Claude Opus; virus and leaked-key scanners to add</a:t>
                       </a:r>
                     </a:p>
                   </a:txBody>
@@ -9110,7 +9110,7 @@
                           </a:solidFill>
                           <a:latin typeface="Arial"/>
                         </a:rPr>
-                        <a:t>Research &amp; planning</a:t>
+                        <a:t>Research and planning</a:t>
                       </a:r>
                     </a:p>
                   </a:txBody>
@@ -9402,7 +9402,7 @@
                           </a:solidFill>
                           <a:latin typeface="Arial"/>
                         </a:rPr>
-                        <a:t>Experiments / evals</a:t>
+                        <a:t>Trying new models</a:t>
                       </a:r>
                     </a:p>
                   </a:txBody>
@@ -9536,7 +9536,7 @@
                 </a:solidFill>
                 <a:latin typeface="Arial"/>
               </a:rPr>
-              <a:t>12 · BUILT AS A PRODUCT</a:t>
+              <a:t>12. BUILT AS A PRODUCT</a:t>
             </a:r>
           </a:p>
         </p:txBody>
@@ -9653,7 +9653,7 @@
                 </a:solidFill>
                 <a:latin typeface="Arial"/>
               </a:rPr>
-              <a:t>DevExAI · proposal draft</a:t>
+              <a:t>DevExAI, proposal draft</a:t>
             </a:r>
           </a:p>
         </p:txBody>
@@ -9817,7 +9817,7 @@
                 </a:solidFill>
                 <a:latin typeface="Arial"/>
               </a:rPr>
-              <a:t>Slack today; Teams, Google Chat, Discord and more through a small adapter</a:t>
+              <a:t>Slack today; Teams, Google Chat, Discord and more with a small add-on each</a:t>
             </a:r>
           </a:p>
         </p:txBody>
@@ -9942,7 +9942,7 @@
                 </a:solidFill>
                 <a:latin typeface="Arial"/>
               </a:rPr>
-              <a:t>Claude today; Gemini and ChatGPT next — subscriptions or API keys</a:t>
+              <a:t>Claude today; Gemini and ChatGPT next. Subscriptions or keys</a:t>
             </a:r>
           </a:p>
         </p:txBody>
@@ -10028,7 +10028,7 @@
                 </a:solidFill>
                 <a:latin typeface="Arial"/>
               </a:rPr>
-              <a:t>Code host</a:t>
+              <a:t>Where code lives</a:t>
             </a:r>
           </a:p>
         </p:txBody>
@@ -10067,7 +10067,7 @@
                 </a:solidFill>
                 <a:latin typeface="Arial"/>
               </a:rPr>
-              <a:t>GitHub, GitLab, Bitbucket, Azure DevOps, self-hosted Git (later)</a:t>
+              <a:t>GitHub, GitLab, Bitbucket and others (later)</a:t>
             </a:r>
           </a:p>
         </p:txBody>
@@ -10153,7 +10153,7 @@
                 </a:solidFill>
                 <a:latin typeface="Arial"/>
               </a:rPr>
-              <a:t>Secret store</a:t>
+              <a:t>Passwords and keys</a:t>
             </a:r>
           </a:p>
         </p:txBody>
@@ -10192,7 +10192,7 @@
                 </a:solidFill>
                 <a:latin typeface="Arial"/>
               </a:rPr>
-              <a:t>A secret file on the server today; Vault or a cloud secret manager</a:t>
+              <a:t>A protected file on the server today; a company vault later</a:t>
             </a:r>
           </a:p>
         </p:txBody>
@@ -10278,7 +10278,7 @@
                 </a:solidFill>
                 <a:latin typeface="Arial"/>
               </a:rPr>
-              <a:t>Blog / website</a:t>
+              <a:t>Blog</a:t>
             </a:r>
           </a:p>
         </p:txBody>
@@ -10317,7 +10317,7 @@
                 </a:solidFill>
                 <a:latin typeface="Arial"/>
               </a:rPr>
-              <a:t>Built into the dashboard; posts are Markdown files any site can show</a:t>
+              <a:t>Built into the dashboard; each post is a web page with an Install it button</a:t>
             </a:r>
           </a:p>
         </p:txBody>
@@ -10528,7 +10528,7 @@
                 </a:solidFill>
                 <a:latin typeface="Arial"/>
               </a:rPr>
-              <a:t>Account pool (planned)</a:t>
+              <a:t>Shared accounts (planned)</a:t>
             </a:r>
           </a:p>
         </p:txBody>
@@ -10567,7 +10567,7 @@
                 </a:solidFill>
                 <a:latin typeface="Arial"/>
               </a:rPr>
-              <a:t>• Several subscriptions and API keys per provider</a:t>
+              <a:t>• Several subscriptions or keys for each AI company</a:t>
             </a:r>
           </a:p>
           <a:p>
@@ -10586,7 +10586,7 @@
                 </a:solidFill>
                 <a:latin typeface="Arial"/>
               </a:rPr>
-              <a:t>• One hits its limit → the next takes over</a:t>
+              <a:t>• When one hits its limit, the next takes over</a:t>
             </a:r>
           </a:p>
           <a:p>
@@ -10624,7 +10624,7 @@
                 </a:solidFill>
                 <a:latin typeface="Arial"/>
               </a:rPr>
-              <a:t>• Keys live in the secret store, never in chat</a:t>
+              <a:t>• Keys stay in the protected file, never in chat</a:t>
             </a:r>
           </a:p>
           <a:p>
@@ -10643,7 +10643,7 @@
                 </a:solidFill>
                 <a:latin typeface="Arial"/>
               </a:rPr>
-              <a:t>• Never swaps to a weaker reviewer: review stays Claude Opus</a:t>
+              <a:t>• Code review always stays with Claude Opus</a:t>
             </a:r>
           </a:p>
           <a:p>
@@ -10662,7 +10662,7 @@
                 </a:solidFill>
                 <a:latin typeface="Arial"/>
               </a:rPr>
-              <a:t>• Check your plans allow a shared bot (business, enterprise or API)</a:t>
+              <a:t>• Check your plans allow a shared bot (business or enterprise)</a:t>
             </a:r>
           </a:p>
         </p:txBody>
@@ -11555,7 +11555,7 @@
                 </a:solidFill>
                 <a:latin typeface="Arial"/>
               </a:rPr>
-              <a:t>13 · COST AND RESOURCES</a:t>
+              <a:t>13. COST AND RESOURCES</a:t>
             </a:r>
           </a:p>
         </p:txBody>
@@ -11672,7 +11672,7 @@
                 </a:solidFill>
                 <a:latin typeface="Arial"/>
               </a:rPr>
-              <a:t>DevExAI · proposal draft</a:t>
+              <a:t>DevExAI, proposal draft</a:t>
             </a:r>
           </a:p>
         </p:txBody>
@@ -11899,7 +11899,7 @@
                 </a:solidFill>
                 <a:latin typeface="Arial"/>
               </a:rPr>
-              <a:t>• Add accounts or keys to the pool when busy</a:t>
+              <a:t>• Add more accounts when busy</a:t>
             </a:r>
           </a:p>
         </p:txBody>
@@ -12069,7 +12069,7 @@
                 </a:solidFill>
                 <a:latin typeface="Arial"/>
               </a:rPr>
-              <a:t>• DeepSeek for cheap extra building — off for now</a:t>
+              <a:t>• DeepSeek for cheap extra building, off for now</a:t>
             </a:r>
           </a:p>
           <a:p>
@@ -12893,7 +12893,7 @@
                 </a:solidFill>
                 <a:latin typeface="Arial"/>
               </a:rPr>
-              <a:t>14 · RULES THE BOT ALWAYS FOLLOWS</a:t>
+              <a:t>14. RULES THE BOT ALWAYS FOLLOWS</a:t>
             </a:r>
           </a:p>
         </p:txBody>
@@ -13010,7 +13010,7 @@
                 </a:solidFill>
                 <a:latin typeface="Arial"/>
               </a:rPr>
-              <a:t>DevExAI · proposal draft</a:t>
+              <a:t>DevExAI, proposal draft</a:t>
             </a:r>
           </a:p>
         </p:txBody>
@@ -13510,7 +13510,7 @@
                 </a:solidFill>
                 <a:latin typeface="Arial"/>
               </a:rPr>
-              <a:t>Company code and summaries are read-only; never sent to unapproved services.</a:t>
+              <a:t>Company code is never changed, or sent to services we have not approved.</a:t>
             </a:r>
           </a:p>
         </p:txBody>
@@ -14823,7 +14823,7 @@
                 </a:solidFill>
                 <a:latin typeface="Arial"/>
               </a:rPr>
-              <a:t>15 · ROLLOUT</a:t>
+              <a:t>15. ROLLOUT</a:t>
             </a:r>
           </a:p>
         </p:txBody>
@@ -14940,7 +14940,7 @@
                 </a:solidFill>
                 <a:latin typeface="Arial"/>
               </a:rPr>
-              <a:t>DevExAI · proposal draft</a:t>
+              <a:t>DevExAI, proposal draft</a:t>
             </a:r>
           </a:p>
         </p:txBody>
@@ -15188,7 +15188,7 @@
                 </a:solidFill>
                 <a:latin typeface="Arial"/>
               </a:rPr>
-              <a:t>Slack intake (our platform), safety gate, plan, dashboard, blog post. One team.</a:t>
+              <a:t>Ideas from Slack, safety check, plan, dashboard, blog. One team.</a:t>
             </a:r>
           </a:p>
         </p:txBody>
@@ -15436,7 +15436,7 @@
                 </a:solidFill>
                 <a:latin typeface="Arial"/>
               </a:rPr>
-              <a:t>Built: builder, Opus review, auto post, install command. Next: tests in a sandbox, account pool.</a:t>
+              <a:t>Built: AI writes the tool, Opus checks it, post, install command. Next: run tests safely, shared accounts.</a:t>
             </a:r>
           </a:p>
         </p:txBody>
@@ -15932,7 +15932,7 @@
                 </a:solidFill>
                 <a:latin typeface="Arial"/>
               </a:rPr>
-              <a:t>Windows package and updater exist. Next: Linux, second chat platform (e.g. Teams).</a:t>
+              <a:t>Windows setup, Linux command and updates exist. Next: Linux server setup, Teams.</a:t>
             </a:r>
           </a:p>
         </p:txBody>
@@ -16180,7 +16180,7 @@
                 </a:solidFill>
                 <a:latin typeface="Arial"/>
               </a:rPr>
-              <a:t>GPU machine for cheap building and evals, if usage justifies it.</a:t>
+              <a:t>A graphics-card machine for cheap building and testing, if usage justifies it.</a:t>
             </a:r>
           </a:p>
         </p:txBody>
@@ -16735,7 +16735,7 @@
                 </a:solidFill>
                 <a:latin typeface="Arial"/>
               </a:rPr>
-              <a:t>“Was this useful?”</a:t>
+              <a:t>"Was this useful?"</a:t>
             </a:r>
           </a:p>
         </p:txBody>
@@ -18456,7 +18456,7 @@
                 </a:solidFill>
                 <a:latin typeface="Arial"/>
               </a:rPr>
-              <a:t>16 · RISKS</a:t>
+              <a:t>16. RISKS</a:t>
             </a:r>
           </a:p>
         </p:txBody>
@@ -18573,7 +18573,7 @@
                 </a:solidFill>
                 <a:latin typeface="Arial"/>
               </a:rPr>
-              <a:t>DevExAI · proposal draft</a:t>
+              <a:t>DevExAI, proposal draft</a:t>
             </a:r>
           </a:p>
         </p:txBody>
@@ -18698,7 +18698,7 @@
                           </a:solidFill>
                           <a:latin typeface="Arial"/>
                         </a:rPr>
-                        <a:t>Two safety checks, human approval, sandboxed builds (next), versions, one-command uninstall, pull a release.</a:t>
+                        <a:t>Two safety checks, human approval, tests on a locked-down machine (next), versions, one-command uninstall, pull a release.</a:t>
                       </a:r>
                     </a:p>
                   </a:txBody>
@@ -18749,7 +18749,7 @@
                           </a:solidFill>
                           <a:latin typeface="Arial"/>
                         </a:rPr>
-                        <a:t>Links read by a separate process as plain data; no secrets while reading.</a:t>
+                        <a:t>Links read by a separate program as plain text, with no keys at hand.</a:t>
                       </a:r>
                     </a:p>
                   </a:txBody>
@@ -18880,7 +18880,7 @@
                           </a:solidFill>
                           <a:latin typeface="Arial"/>
                         </a:rPr>
-                        <a:t>Account pool breaks provider terms</a:t>
+                        <a:t>Shared accounts break AI company terms</a:t>
                       </a:r>
                     </a:p>
                   </a:txBody>
@@ -18902,7 +18902,7 @@
                           </a:solidFill>
                           <a:latin typeface="Arial"/>
                         </a:rPr>
-                        <a:t>Business, enterprise plans or API keys recommended; each company checks its plans.</a:t>
+                        <a:t>Business or enterprise plans recommended; each company checks its plans.</a:t>
                       </a:r>
                     </a:p>
                   </a:txBody>
@@ -18953,7 +18953,7 @@
                           </a:solidFill>
                           <a:latin typeface="Arial"/>
                         </a:rPr>
-                        <a:t>Duplicate check, “not now” label, simple priority queue.</a:t>
+                        <a:t>Repeat-idea check, a "not now" label, a simple priority list.</a:t>
                       </a:r>
                     </a:p>
                   </a:txBody>
@@ -19094,7 +19094,7 @@
                 </a:solidFill>
                 <a:latin typeface="Arial"/>
               </a:rPr>
-              <a:t>17 · DECISIONS</a:t>
+              <a:t>17. DECISIONS</a:t>
             </a:r>
           </a:p>
         </p:txBody>
@@ -19211,7 +19211,7 @@
                 </a:solidFill>
                 <a:latin typeface="Arial"/>
               </a:rPr>
-              <a:t>DevExAI · proposal draft</a:t>
+              <a:t>DevExAI, proposal draft</a:t>
             </a:r>
           </a:p>
         </p:txBody>
@@ -19629,7 +19629,7 @@
                 </a:solidFill>
                 <a:latin typeface="Arial"/>
               </a:rPr>
-              <a:t>Posts are Markdown files, served by the dashboard's own blog page.</a:t>
+              <a:t>Each post is a web page on the dashboard's blog, with an Install it button.</a:t>
             </a:r>
           </a:p>
         </p:txBody>
@@ -21447,7 +21447,7 @@
                 </a:solidFill>
                 <a:latin typeface="Arial"/>
               </a:rPr>
-              <a:t>Full details: README.md in the DevExAI project.</a:t>
+              <a:t>Full details: the README in the DevExAI project.</a:t>
             </a:r>
           </a:p>
         </p:txBody>
@@ -22043,7 +22043,7 @@
                 </a:solidFill>
                 <a:latin typeface="Arial"/>
               </a:rPr>
-              <a:t>01 · THE PROBLEM</a:t>
+              <a:t>1. THE PROBLEM</a:t>
             </a:r>
           </a:p>
         </p:txBody>
@@ -22160,7 +22160,7 @@
                 </a:solidFill>
                 <a:latin typeface="Arial"/>
               </a:rPr>
-              <a:t>DevExAI · proposal draft</a:t>
+              <a:t>DevExAI, proposal draft</a:t>
             </a:r>
           </a:p>
         </p:txBody>
@@ -22374,7 +22374,7 @@
                 </a:solidFill>
                 <a:latin typeface="Arial"/>
               </a:rPr>
-              <a:t>A blog post, a GitHub repo, a new prompt, a new MCP server that makes AI coding or code review better.</a:t>
+              <a:t>A blog post, a code project, a new prompt, a new add-on that makes AI coding or code review better.</a:t>
             </a:r>
           </a:p>
         </p:txBody>
@@ -23506,7 +23506,7 @@
                 </a:solidFill>
                 <a:latin typeface="Arial"/>
               </a:rPr>
-              <a:t>02 · THE IDEA</a:t>
+              <a:t>2. THE IDEA</a:t>
             </a:r>
           </a:p>
         </p:txBody>
@@ -23623,7 +23623,7 @@
                 </a:solidFill>
                 <a:latin typeface="Arial"/>
               </a:rPr>
-              <a:t>DevExAI · proposal draft</a:t>
+              <a:t>DevExAI, proposal draft</a:t>
             </a:r>
           </a:p>
         </p:txBody>
@@ -24340,7 +24340,7 @@
                 </a:solidFill>
                 <a:latin typeface="Arial"/>
               </a:rPr>
-              <a:t>Claude Opus researches with our project context.</a:t>
+              <a:t>Claude Opus reads up and writes a plan.</a:t>
             </a:r>
           </a:p>
         </p:txBody>
@@ -24594,7 +24594,7 @@
                 </a:solidFill>
                 <a:latin typeface="Arial"/>
               </a:rPr>
-              <a:t>The builder AI writes the code, tests and README.</a:t>
+              <a:t>The AI writes the code, tests and a how-to.</a:t>
             </a:r>
           </a:p>
         </p:txBody>
@@ -24848,7 +24848,7 @@
                 </a:solidFill>
                 <a:latin typeface="Arial"/>
               </a:rPr>
-              <a:t>Opus reviews every line; a human approves.</a:t>
+              <a:t>Opus checks every line. A person approves.</a:t>
             </a:r>
           </a:p>
         </p:txBody>
@@ -25102,7 +25102,7 @@
                 </a:solidFill>
                 <a:latin typeface="Arial"/>
               </a:rPr>
-              <a:t>Short post with install steps; idea credited.</a:t>
+              <a:t>A short post. The poster is named.</a:t>
             </a:r>
           </a:p>
         </p:txBody>
@@ -27018,7 +27018,7 @@
                 </a:solidFill>
                 <a:latin typeface="Arial"/>
               </a:rPr>
-              <a:t>03 · WHO IS INVOLVED</a:t>
+              <a:t>3. WHO IS INVOLVED</a:t>
             </a:r>
           </a:p>
         </p:txBody>
@@ -27135,7 +27135,7 @@
                 </a:solidFill>
                 <a:latin typeface="Arial"/>
               </a:rPr>
-              <a:t>DevExAI · proposal draft</a:t>
+              <a:t>DevExAI, proposal draft</a:t>
             </a:r>
           </a:p>
         </p:txBody>
@@ -27305,7 +27305,7 @@
                 </a:solidFill>
                 <a:latin typeface="Arial"/>
               </a:rPr>
-              <a:t>Any colleague. Sends an idea — text, links, or both — to the bot.</a:t>
+              <a:t>Any colleague. Sends an idea to the bot: text, links, or both.</a:t>
             </a:r>
           </a:p>
         </p:txBody>
@@ -27475,7 +27475,7 @@
                 </a:solidFill>
                 <a:latin typeface="Arial"/>
               </a:rPr>
-              <a:t>A small group. Approve plans, paid resources and releases, decide unsure cases, own the project summaries. Admins add them in the dashboard.</a:t>
+              <a:t>A small group. Approve plans, paid resources and releases, decide unsure cases, keep the project summaries current. Admins add them in the dashboard.</a:t>
             </a:r>
           </a:p>
         </p:txBody>
@@ -27940,7 +27940,7 @@
                 </a:solidFill>
                 <a:latin typeface="Arial"/>
               </a:rPr>
-              <a:t>Topic match (e.g. Android, backend, security)</a:t>
+              <a:t>Topic match, like Android or security</a:t>
             </a:r>
           </a:p>
         </p:txBody>
@@ -28071,7 +28071,7 @@
                 </a:solidFill>
                 <a:latin typeface="Arial"/>
               </a:rPr>
-              <a:t>Otherwise round-robin</a:t>
+              <a:t>Otherwise, take turns</a:t>
             </a:r>
           </a:p>
         </p:txBody>
@@ -28202,7 +28202,7 @@
                 </a:solidFill>
                 <a:latin typeface="Arial"/>
               </a:rPr>
-              <a:t>No reply within 24 hours → next maintainer, everyone told</a:t>
+              <a:t>No reply in 24 hours: next maintainer, everyone told</a:t>
             </a:r>
           </a:p>
         </p:txBody>
@@ -29266,7 +29266,7 @@
                 </a:solidFill>
                 <a:latin typeface="Arial"/>
               </a:rPr>
-              <a:t>04 · HOW AN IDEA TRAVELS</a:t>
+              <a:t>4. HOW AN IDEA TRAVELS</a:t>
             </a:r>
           </a:p>
         </p:txBody>
@@ -29383,7 +29383,7 @@
                 </a:solidFill>
                 <a:latin typeface="Arial"/>
               </a:rPr>
-              <a:t>DevExAI · proposal draft</a:t>
+              <a:t>DevExAI, proposal draft</a:t>
             </a:r>
           </a:p>
         </p:txBody>
@@ -29592,7 +29592,7 @@
                 </a:solidFill>
                 <a:latin typeface="Arial"/>
               </a:rPr>
-              <a:t>Text and/or links to the bot. Gets a tracking number and a thread.</a:t>
+              <a:t>Text, links, or both, to the bot. Gets a tracking number and a thread.</a:t>
             </a:r>
           </a:p>
         </p:txBody>
@@ -30010,7 +30010,7 @@
                 </a:solidFill>
                 <a:latin typeface="Arial"/>
               </a:rPr>
-              <a:t>Reads links, flags duplicates, uses project summaries.</a:t>
+              <a:t>Reads links, spots repeat ideas, uses project summaries.</a:t>
             </a:r>
           </a:p>
         </p:txBody>
@@ -30598,7 +30598,7 @@
                 </a:solidFill>
                 <a:latin typeface="Arial"/>
               </a:rPr>
-              <a:t>Build &amp; test</a:t>
+              <a:t>Build</a:t>
             </a:r>
           </a:p>
         </p:txBody>
@@ -30637,7 +30637,7 @@
                 </a:solidFill>
                 <a:latin typeface="Arial"/>
               </a:rPr>
-              <a:t>Builder writes code, tests and a README. Running tests in a sandbox is next.</a:t>
+              <a:t>The AI writes the code, tests and a how-to. Running the tests safely is next.</a:t>
             </a:r>
           </a:p>
         </p:txBody>
@@ -30846,7 +30846,7 @@
                 </a:solidFill>
                 <a:latin typeface="Arial"/>
               </a:rPr>
-              <a:t>Opus review with a safety check, one fix round, human final yes.</a:t>
+              <a:t>Opus checks safety and quality, one round of fixes, then a person says yes.</a:t>
             </a:r>
           </a:p>
         </p:txBody>
@@ -31055,7 +31055,7 @@
                 </a:solidFill>
                 <a:latin typeface="Arial"/>
               </a:rPr>
-              <a:t>Versioned release, short blog post, poster credited.</a:t>
+              <a:t>Numbered release, a short blog post, the poster named.</a:t>
             </a:r>
           </a:p>
         </p:txBody>
@@ -32686,7 +32686,7 @@
                 </a:solidFill>
                 <a:latin typeface="Arial"/>
               </a:rPr>
-              <a:t>05 · STRICT SAFETY GATE</a:t>
+              <a:t>5. STRICT SAFETY GATE</a:t>
             </a:r>
           </a:p>
         </p:txBody>
@@ -32803,7 +32803,7 @@
                 </a:solidFill>
                 <a:latin typeface="Arial"/>
               </a:rPr>
-              <a:t>DevExAI · proposal draft</a:t>
+              <a:t>DevExAI, proposal draft</a:t>
             </a:r>
           </a:p>
         </p:txBody>
@@ -33014,7 +33014,7 @@
                 </a:solidFill>
                 <a:latin typeface="Arial"/>
               </a:rPr>
-              <a:t>Malware, credential stealers, miners, hidden network calls</a:t>
+              <a:t>Harmful software, password stealers, hidden data sending</a:t>
             </a:r>
           </a:p>
         </p:txBody>
@@ -33772,7 +33772,7 @@
                 </a:solidFill>
                 <a:latin typeface="Arial"/>
               </a:rPr>
-              <a:t>Links are read by a separate process with no secrets, never on a laptop. The review checks the finished code for safety again.</a:t>
+              <a:t>Links are read by a separate program that holds no passwords or keys, never on a laptop. The finished code is checked for safety again.</a:t>
             </a:r>
           </a:p>
         </p:txBody>
@@ -34746,7 +34746,7 @@
                 </a:solidFill>
                 <a:latin typeface="Arial"/>
               </a:rPr>
-              <a:t>06 · RESOURCES</a:t>
+              <a:t>6. RESOURCES</a:t>
             </a:r>
           </a:p>
         </p:txBody>
@@ -34863,7 +34863,7 @@
                 </a:solidFill>
                 <a:latin typeface="Arial"/>
               </a:rPr>
-              <a:t>DevExAI · proposal draft</a:t>
+              <a:t>DevExAI, proposal draft</a:t>
             </a:r>
           </a:p>
         </p:txBody>
@@ -34997,7 +34997,7 @@
                 </a:solidFill>
                 <a:latin typeface="Arial"/>
               </a:rPr>
-              <a:t>Free and needs no account: open-source libraries, public docs, free public APIs without a key.</a:t>
+              <a:t>Free and needs no account: open-source libraries, public docs, free public services that need no key.</a:t>
             </a:r>
           </a:p>
         </p:txBody>
@@ -35179,7 +35179,7 @@
                 </a:solidFill>
                 <a:latin typeface="Arial"/>
               </a:rPr>
-              <a:t>Paid, behind a login, or needs an API key, a licence or a new account.</a:t>
+              <a:t>Paid, behind a login, or needs a key, a licence or a new account.</a:t>
             </a:r>
           </a:p>
         </p:txBody>
@@ -35571,7 +35571,7 @@
                 </a:solidFill>
                 <a:latin typeface="Arial"/>
               </a:rPr>
-              <a:t>The bot never creates accounts, enters passwords or spends money. Keys go into the server's secret file, never into chat.</a:t>
+              <a:t>The bot never creates accounts, enters passwords or spends money. Keys go into a protected file on the server, never into chat.</a:t>
             </a:r>
           </a:p>
           <a:p>
@@ -35590,7 +35590,7 @@
                 </a:solidFill>
                 <a:latin typeface="Arial"/>
               </a:rPr>
-              <a:t>The fast lane only skips resource approval — every release still needs a human yes.</a:t>
+              <a:t>The fast lane only skips this question. Every release still needs a person's yes.</a:t>
             </a:r>
           </a:p>
         </p:txBody>
@@ -36312,7 +36312,7 @@
                 </a:solidFill>
                 <a:latin typeface="Arial"/>
               </a:rPr>
-              <a:t>07 · REVIEW AND APPROVE</a:t>
+              <a:t>7. REVIEW AND APPROVE</a:t>
             </a:r>
           </a:p>
         </p:txBody>
@@ -36429,7 +36429,7 @@
                 </a:solidFill>
                 <a:latin typeface="Arial"/>
               </a:rPr>
-              <a:t>DevExAI · proposal draft</a:t>
+              <a:t>DevExAI, proposal draft</a:t>
             </a:r>
           </a:p>
         </p:txBody>
@@ -38140,7 +38140,7 @@
                 </a:solidFill>
                 <a:latin typeface="Arial"/>
               </a:rPr>
-              <a:t>08 · KEEPING PEOPLE INFORMED</a:t>
+              <a:t>8. KEEPING PEOPLE INFORMED</a:t>
             </a:r>
           </a:p>
         </p:txBody>
@@ -38257,7 +38257,7 @@
                 </a:solidFill>
                 <a:latin typeface="Arial"/>
               </a:rPr>
-              <a:t>DevExAI · proposal draft</a:t>
+              <a:t>DevExAI, proposal draft</a:t>
             </a:r>
           </a:p>
         </p:txBody>
@@ -39254,7 +39254,7 @@
                 </a:solidFill>
                 <a:latin typeface="Arial"/>
               </a:rPr>
-              <a:t>“Waiting for approval” appears only when a paid resource or login is needed. A “Testing” stage joins once builds run in a sandbox.</a:t>
+              <a:t>"Waiting for approval" appears only when a paid resource or login is needed. A "Testing" stage joins once tests can run safely.</a:t>
             </a:r>
           </a:p>
         </p:txBody>

</xml_diff>